<commit_message>
Add Varieties sheet to the Honduras area-drivers workbook
Year-by-year rust-resistant share (surveys 2013, 2014, 2017, 2020, each marked
read or unverified), Lempira share, events (releases, resistance loss, new
strains, renovation programmes), the IHCAFE releases, and an editable estimate
of the share still resistant after Lempira broke in April 2017. The deck and
the finance workbook pick up the new adoption points.

Co-Authored-By: Claude Opus 5.5 <noreply@anthropic.com>
Claude-Session: https://claude.ai/code/session_01GCSUFXh2mYdWNgg7VCeE1G
</commit_message>
<xml_diff>
--- a/research/honduras/slides/Honduras_price_finance_varieties.pptx
+++ b/research/honduras/slides/Honduras_price_finance_varieties.pptx
@@ -9293,7 +9293,7 @@
         <p:spPr>
           <a:xfrm>
             <a:off x="8001000" y="2167128"/>
-            <a:ext cx="685800" cy="457200"/>
+            <a:ext cx="685800" cy="365760"/>
           </a:xfrm>
           <a:prstGeom prst="rect">
             <a:avLst/>
@@ -9342,7 +9342,7 @@
         <p:spPr>
           <a:xfrm>
             <a:off x="8686800" y="2167128"/>
-            <a:ext cx="2103120" cy="457200"/>
+            <a:ext cx="2103120" cy="365760"/>
           </a:xfrm>
           <a:prstGeom prst="rect">
             <a:avLst/>
@@ -9391,7 +9391,7 @@
         <p:spPr>
           <a:xfrm>
             <a:off x="10789920" y="2167128"/>
-            <a:ext cx="1188720" cy="457200"/>
+            <a:ext cx="1188720" cy="365760"/>
           </a:xfrm>
           <a:prstGeom prst="rect">
             <a:avLst/>
@@ -9439,8 +9439,8 @@
         </p:nvSpPr>
         <p:spPr>
           <a:xfrm>
-            <a:off x="8001000" y="2624328"/>
-            <a:ext cx="685800" cy="457200"/>
+            <a:off x="8001000" y="2532888"/>
+            <a:ext cx="685800" cy="365760"/>
           </a:xfrm>
           <a:prstGeom prst="rect">
             <a:avLst/>
@@ -9488,8 +9488,8 @@
         </p:nvSpPr>
         <p:spPr>
           <a:xfrm>
-            <a:off x="8686800" y="2624328"/>
-            <a:ext cx="2103120" cy="457200"/>
+            <a:off x="8686800" y="2532888"/>
+            <a:ext cx="2103120" cy="365760"/>
           </a:xfrm>
           <a:prstGeom prst="rect">
             <a:avLst/>
@@ -9537,8 +9537,8 @@
         </p:nvSpPr>
         <p:spPr>
           <a:xfrm>
-            <a:off x="10789920" y="2624328"/>
-            <a:ext cx="1188720" cy="457200"/>
+            <a:off x="10789920" y="2532888"/>
+            <a:ext cx="1188720" cy="365760"/>
           </a:xfrm>
           <a:prstGeom prst="rect">
             <a:avLst/>
@@ -9586,8 +9586,8 @@
         </p:nvSpPr>
         <p:spPr>
           <a:xfrm>
-            <a:off x="8001000" y="3081528"/>
-            <a:ext cx="685800" cy="457200"/>
+            <a:off x="8001000" y="2898648"/>
+            <a:ext cx="685800" cy="365760"/>
           </a:xfrm>
           <a:prstGeom prst="rect">
             <a:avLst/>
@@ -9635,8 +9635,8 @@
         </p:nvSpPr>
         <p:spPr>
           <a:xfrm>
-            <a:off x="8686800" y="3081528"/>
-            <a:ext cx="2103120" cy="457200"/>
+            <a:off x="8686800" y="2898648"/>
+            <a:ext cx="2103120" cy="365760"/>
           </a:xfrm>
           <a:prstGeom prst="rect">
             <a:avLst/>
@@ -9684,8 +9684,8 @@
         </p:nvSpPr>
         <p:spPr>
           <a:xfrm>
-            <a:off x="10789920" y="3081528"/>
-            <a:ext cx="1188720" cy="457200"/>
+            <a:off x="10789920" y="2898648"/>
+            <a:ext cx="1188720" cy="365760"/>
           </a:xfrm>
           <a:prstGeom prst="rect">
             <a:avLst/>
@@ -9733,8 +9733,8 @@
         </p:nvSpPr>
         <p:spPr>
           <a:xfrm>
-            <a:off x="8001000" y="3538728"/>
-            <a:ext cx="685800" cy="457200"/>
+            <a:off x="8001000" y="3264408"/>
+            <a:ext cx="685800" cy="365760"/>
           </a:xfrm>
           <a:prstGeom prst="rect">
             <a:avLst/>
@@ -9782,8 +9782,8 @@
         </p:nvSpPr>
         <p:spPr>
           <a:xfrm>
-            <a:off x="8686800" y="3538728"/>
-            <a:ext cx="2103120" cy="457200"/>
+            <a:off x="8686800" y="3264408"/>
+            <a:ext cx="2103120" cy="365760"/>
           </a:xfrm>
           <a:prstGeom prst="rect">
             <a:avLst/>
@@ -9831,8 +9831,8 @@
         </p:nvSpPr>
         <p:spPr>
           <a:xfrm>
-            <a:off x="10789920" y="3538728"/>
-            <a:ext cx="1188720" cy="457200"/>
+            <a:off x="10789920" y="3264408"/>
+            <a:ext cx="1188720" cy="365760"/>
           </a:xfrm>
           <a:prstGeom prst="rect">
             <a:avLst/>
@@ -9880,8 +9880,302 @@
         </p:nvSpPr>
         <p:spPr>
           <a:xfrm>
+            <a:off x="8001000" y="3630168"/>
+            <a:ext cx="685800" cy="365760"/>
+          </a:xfrm>
+          <a:prstGeom prst="rect">
+            <a:avLst/>
+          </a:prstGeom>
+          <a:solidFill>
+            <a:srgbClr val="FFFFFF"/>
+          </a:solidFill>
+          <a:ln>
+            <a:noFill/>
+          </a:ln>
+        </p:spPr>
+        <p:txBody>
+          <a:bodyPr wrap="square" lIns="36576" tIns="27432" rIns="36576" bIns="27432" anchor="ctr" rtlCol="0">
+            <a:noAutofit/>
+          </a:bodyPr>
+          <a:lstStyle/>
+          <a:p>
+            <a:pPr algn="l" marL="0" indent="0">
+              <a:spcBef>
+                <a:spcPts val="0"/>
+              </a:spcBef>
+              <a:spcAft>
+                <a:spcPts val="0"/>
+              </a:spcAft>
+              <a:buNone/>
+            </a:pPr>
+            <a:r>
+              <a:rPr lang="en-GB" sz="750" dirty="0">
+                <a:solidFill>
+                  <a:srgbClr val="262626"/>
+                </a:solidFill>
+                <a:latin typeface="Arial"/>
+                <a:cs typeface="Arial"/>
+              </a:rPr>
+              <a:t>Aug 2017</a:t>
+            </a:r>
+          </a:p>
+        </p:txBody>
+      </p:sp>
+      <p:sp>
+        <p:nvSpPr>
+          <p:cNvPr id="69" name="TextBox 69"/>
+          <p:cNvSpPr txBox="1"/>
+          <p:nvPr/>
+        </p:nvSpPr>
+        <p:spPr>
+          <a:xfrm>
+            <a:off x="8686800" y="3630168"/>
+            <a:ext cx="2103120" cy="365760"/>
+          </a:xfrm>
+          <a:prstGeom prst="rect">
+            <a:avLst/>
+          </a:prstGeom>
+          <a:solidFill>
+            <a:srgbClr val="FFFFFF"/>
+          </a:solidFill>
+          <a:ln>
+            <a:noFill/>
+          </a:ln>
+        </p:spPr>
+        <p:txBody>
+          <a:bodyPr wrap="square" lIns="36576" tIns="27432" rIns="36576" bIns="27432" anchor="ctr" rtlCol="0">
+            <a:noAutofit/>
+          </a:bodyPr>
+          <a:lstStyle/>
+          <a:p>
+            <a:pPr algn="ctr" marL="0" indent="0">
+              <a:spcBef>
+                <a:spcPts val="0"/>
+              </a:spcBef>
+              <a:spcAft>
+                <a:spcPts val="0"/>
+              </a:spcAft>
+              <a:buNone/>
+            </a:pPr>
+            <a:r>
+              <a:rPr lang="en-GB" sz="750" dirty="0">
+                <a:solidFill>
+                  <a:srgbClr val="262626"/>
+                </a:solidFill>
+                <a:latin typeface="Arial"/>
+                <a:cs typeface="Arial"/>
+              </a:rPr>
+              <a:t>60 % of the park; seed: 65 % Lempira</a:t>
+            </a:r>
+          </a:p>
+        </p:txBody>
+      </p:sp>
+      <p:sp>
+        <p:nvSpPr>
+          <p:cNvPr id="70" name="TextBox 70"/>
+          <p:cNvSpPr txBox="1"/>
+          <p:nvPr/>
+        </p:nvSpPr>
+        <p:spPr>
+          <a:xfrm>
+            <a:off x="10789920" y="3630168"/>
+            <a:ext cx="1188720" cy="365760"/>
+          </a:xfrm>
+          <a:prstGeom prst="rect">
+            <a:avLst/>
+          </a:prstGeom>
+          <a:solidFill>
+            <a:srgbClr val="FFFFFF"/>
+          </a:solidFill>
+          <a:ln>
+            <a:noFill/>
+          </a:ln>
+        </p:spPr>
+        <p:txBody>
+          <a:bodyPr wrap="square" lIns="36576" tIns="27432" rIns="36576" bIns="27432" anchor="ctr" rtlCol="0">
+            <a:noAutofit/>
+          </a:bodyPr>
+          <a:lstStyle/>
+          <a:p>
+            <a:pPr algn="ctr" marL="0" indent="0">
+              <a:spcBef>
+                <a:spcPts val="0"/>
+              </a:spcBef>
+              <a:spcAft>
+                <a:spcPts val="0"/>
+              </a:spcAft>
+              <a:buNone/>
+            </a:pPr>
+            <a:r>
+              <a:rPr lang="en-GB" sz="750" dirty="0">
+                <a:solidFill>
+                  <a:srgbClr val="262626"/>
+                </a:solidFill>
+                <a:latin typeface="Arial"/>
+                <a:cs typeface="Arial"/>
+              </a:rPr>
+              <a:t>⚠ La Prensa, 25 Aug 2017</a:t>
+            </a:r>
+          </a:p>
+        </p:txBody>
+      </p:sp>
+      <p:sp>
+        <p:nvSpPr>
+          <p:cNvPr id="71" name="TextBox 71"/>
+          <p:cNvSpPr txBox="1"/>
+          <p:nvPr/>
+        </p:nvSpPr>
+        <p:spPr>
+          <a:xfrm>
             <a:off x="8001000" y="3995928"/>
-            <a:ext cx="685800" cy="457200"/>
+            <a:ext cx="685800" cy="365760"/>
+          </a:xfrm>
+          <a:prstGeom prst="rect">
+            <a:avLst/>
+          </a:prstGeom>
+          <a:solidFill>
+            <a:srgbClr val="F2F5F8"/>
+          </a:solidFill>
+          <a:ln>
+            <a:noFill/>
+          </a:ln>
+        </p:spPr>
+        <p:txBody>
+          <a:bodyPr wrap="square" lIns="36576" tIns="27432" rIns="36576" bIns="27432" anchor="ctr" rtlCol="0">
+            <a:noAutofit/>
+          </a:bodyPr>
+          <a:lstStyle/>
+          <a:p>
+            <a:pPr algn="l" marL="0" indent="0">
+              <a:spcBef>
+                <a:spcPts val="0"/>
+              </a:spcBef>
+              <a:spcAft>
+                <a:spcPts val="0"/>
+              </a:spcAft>
+              <a:buNone/>
+            </a:pPr>
+            <a:r>
+              <a:rPr lang="en-GB" sz="750" dirty="0">
+                <a:solidFill>
+                  <a:srgbClr val="262626"/>
+                </a:solidFill>
+                <a:latin typeface="Arial"/>
+                <a:cs typeface="Arial"/>
+              </a:rPr>
+              <a:t>Oct 2017</a:t>
+            </a:r>
+          </a:p>
+        </p:txBody>
+      </p:sp>
+      <p:sp>
+        <p:nvSpPr>
+          <p:cNvPr id="72" name="TextBox 72"/>
+          <p:cNvSpPr txBox="1"/>
+          <p:nvPr/>
+        </p:nvSpPr>
+        <p:spPr>
+          <a:xfrm>
+            <a:off x="8686800" y="3995928"/>
+            <a:ext cx="2103120" cy="365760"/>
+          </a:xfrm>
+          <a:prstGeom prst="rect">
+            <a:avLst/>
+          </a:prstGeom>
+          <a:solidFill>
+            <a:srgbClr val="F2F5F8"/>
+          </a:solidFill>
+          <a:ln>
+            <a:noFill/>
+          </a:ln>
+        </p:spPr>
+        <p:txBody>
+          <a:bodyPr wrap="square" lIns="36576" tIns="27432" rIns="36576" bIns="27432" anchor="ctr" rtlCol="0">
+            <a:noAutofit/>
+          </a:bodyPr>
+          <a:lstStyle/>
+          <a:p>
+            <a:pPr algn="ctr" marL="0" indent="0">
+              <a:spcBef>
+                <a:spcPts val="0"/>
+              </a:spcBef>
+              <a:spcAft>
+                <a:spcPts val="0"/>
+              </a:spcAft>
+              <a:buNone/>
+            </a:pPr>
+            <a:r>
+              <a:rPr lang="en-GB" sz="750" dirty="0">
+                <a:solidFill>
+                  <a:srgbClr val="262626"/>
+                </a:solidFill>
+                <a:latin typeface="Arial"/>
+                <a:cs typeface="Arial"/>
+              </a:rPr>
+              <a:t>Lempira alone = 56,08 % of sampled farms</a:t>
+            </a:r>
+          </a:p>
+        </p:txBody>
+      </p:sp>
+      <p:sp>
+        <p:nvSpPr>
+          <p:cNvPr id="73" name="TextBox 73"/>
+          <p:cNvSpPr txBox="1"/>
+          <p:nvPr/>
+        </p:nvSpPr>
+        <p:spPr>
+          <a:xfrm>
+            <a:off x="10789920" y="3995928"/>
+            <a:ext cx="1188720" cy="365760"/>
+          </a:xfrm>
+          <a:prstGeom prst="rect">
+            <a:avLst/>
+          </a:prstGeom>
+          <a:solidFill>
+            <a:srgbClr val="F2F5F8"/>
+          </a:solidFill>
+          <a:ln>
+            <a:noFill/>
+          </a:ln>
+        </p:spPr>
+        <p:txBody>
+          <a:bodyPr wrap="square" lIns="36576" tIns="27432" rIns="36576" bIns="27432" anchor="ctr" rtlCol="0">
+            <a:noAutofit/>
+          </a:bodyPr>
+          <a:lstStyle/>
+          <a:p>
+            <a:pPr algn="ctr" marL="0" indent="0">
+              <a:spcBef>
+                <a:spcPts val="0"/>
+              </a:spcBef>
+              <a:spcAft>
+                <a:spcPts val="0"/>
+              </a:spcAft>
+              <a:buNone/>
+            </a:pPr>
+            <a:r>
+              <a:rPr lang="en-GB" sz="750" dirty="0">
+                <a:solidFill>
+                  <a:srgbClr val="262626"/>
+                </a:solidFill>
+                <a:latin typeface="Arial"/>
+                <a:cs typeface="Arial"/>
+              </a:rPr>
+              <a:t>⚠ IHCAFE SAT bulletin No 8</a:t>
+            </a:r>
+          </a:p>
+        </p:txBody>
+      </p:sp>
+      <p:sp>
+        <p:nvSpPr>
+          <p:cNvPr id="74" name="TextBox 74"/>
+          <p:cNvSpPr txBox="1"/>
+          <p:nvPr/>
+        </p:nvSpPr>
+        <p:spPr>
+          <a:xfrm>
+            <a:off x="8001000" y="4361688"/>
+            <a:ext cx="685800" cy="365760"/>
           </a:xfrm>
           <a:prstGeom prst="rect">
             <a:avLst/>
@@ -9916,21 +10210,21 @@
                 <a:latin typeface="Arial"/>
                 <a:cs typeface="Arial"/>
               </a:rPr>
-              <a:t>Oct 2017</a:t>
-            </a:r>
-          </a:p>
-        </p:txBody>
-      </p:sp>
-      <p:sp>
-        <p:nvSpPr>
-          <p:cNvPr id="69" name="TextBox 69"/>
-          <p:cNvSpPr txBox="1"/>
-          <p:nvPr/>
-        </p:nvSpPr>
-        <p:spPr>
-          <a:xfrm>
-            <a:off x="8686800" y="3995928"/>
-            <a:ext cx="2103120" cy="457200"/>
+              <a:t>~2020</a:t>
+            </a:r>
+          </a:p>
+        </p:txBody>
+      </p:sp>
+      <p:sp>
+        <p:nvSpPr>
+          <p:cNvPr id="75" name="TextBox 75"/>
+          <p:cNvSpPr txBox="1"/>
+          <p:nvPr/>
+        </p:nvSpPr>
+        <p:spPr>
+          <a:xfrm>
+            <a:off x="8686800" y="4361688"/>
+            <a:ext cx="2103120" cy="365760"/>
           </a:xfrm>
           <a:prstGeom prst="rect">
             <a:avLst/>
@@ -9965,21 +10259,21 @@
                 <a:latin typeface="Arial"/>
                 <a:cs typeface="Arial"/>
               </a:rPr>
-              <a:t>Lempira alone = 56,08 % of sampled farms</a:t>
-            </a:r>
-          </a:p>
-        </p:txBody>
-      </p:sp>
-      <p:sp>
-        <p:nvSpPr>
-          <p:cNvPr id="70" name="TextBox 70"/>
-          <p:cNvSpPr txBox="1"/>
-          <p:nvPr/>
-        </p:nvSpPr>
-        <p:spPr>
-          <a:xfrm>
-            <a:off x="10789920" y="3995928"/>
-            <a:ext cx="1188720" cy="457200"/>
+              <a:t>60 % of cultivation</a:t>
+            </a:r>
+          </a:p>
+        </p:txBody>
+      </p:sp>
+      <p:sp>
+        <p:nvSpPr>
+          <p:cNvPr id="76" name="TextBox 76"/>
+          <p:cNvSpPr txBox="1"/>
+          <p:nvPr/>
+        </p:nvSpPr>
+        <p:spPr>
+          <a:xfrm>
+            <a:off x="10789920" y="4361688"/>
+            <a:ext cx="1188720" cy="365760"/>
           </a:xfrm>
           <a:prstGeom prst="rect">
             <a:avLst/>
@@ -10014,20 +10308,20 @@
                 <a:latin typeface="Arial"/>
                 <a:cs typeface="Arial"/>
               </a:rPr>
-              <a:t>⚠ IHCAFE SAT bulletin No 8</a:t>
-            </a:r>
-          </a:p>
-        </p:txBody>
-      </p:sp>
-      <p:sp>
-        <p:nvSpPr>
-          <p:cNvPr id="71" name="TextBox 71"/>
-          <p:cNvSpPr txBox="1"/>
-          <p:nvPr/>
-        </p:nvSpPr>
-        <p:spPr>
-          <a:xfrm>
-            <a:off x="8001000" y="4526280"/>
+              <a:t>⚠ Perfect Daily Grind, Mar 2020</a:t>
+            </a:r>
+          </a:p>
+        </p:txBody>
+      </p:sp>
+      <p:sp>
+        <p:nvSpPr>
+          <p:cNvPr id="77" name="TextBox 77"/>
+          <p:cNvSpPr txBox="1"/>
+          <p:nvPr/>
+        </p:nvSpPr>
+        <p:spPr>
+          <a:xfrm>
+            <a:off x="8001000" y="4800600"/>
             <a:ext cx="3977640" cy="1097280"/>
           </a:xfrm>
           <a:prstGeom prst="rect">
@@ -10148,11 +10442,32 @@
               <a:t>Still called resistant by IHCAFE in 2020: Parainema only</a:t>
             </a:r>
           </a:p>
-        </p:txBody>
-      </p:sp>
-      <p:sp>
-        <p:nvSpPr>
-          <p:cNvPr id="72" name="TextBox 72"/>
+          <a:p>
+            <a:pPr algn="l" marL="0" indent="0">
+              <a:spcBef>
+                <a:spcPts val="0"/>
+              </a:spcBef>
+              <a:spcAft>
+                <a:spcPts val="0"/>
+              </a:spcAft>
+              <a:buNone/>
+            </a:pPr>
+            <a:r>
+              <a:rPr lang="en-GB" sz="800" b="1" dirty="0">
+                <a:solidFill>
+                  <a:srgbClr val="C00000"/>
+                </a:solidFill>
+                <a:latin typeface="Arial"/>
+                <a:cs typeface="Arial"/>
+              </a:rPr>
+              <a:t>After Lempira broke: ≈ 3–4 % of the park still resistant ⚠</a:t>
+            </a:r>
+          </a:p>
+        </p:txBody>
+      </p:sp>
+      <p:sp>
+        <p:nvSpPr>
+          <p:cNvPr id="78" name="TextBox 78"/>
           <p:cNvSpPr txBox="1"/>
           <p:nvPr/>
         </p:nvSpPr>

</xml_diff>

<commit_message>
Correct the Honduras variety facts and the post-2017 resistant-share estimate
The share of monitored farms still holding a resistant variety after Lempira
failed is about 17 % (IHCAFE bulletin No 8 alone: 56.08 / 67.74), not 3-4 %
(which mixed two different samples). Parainema is shown as resistant only up
to the last explicit statement (May 2021), IHCAFE 90 as partial from 2017,
Lempira as weakening from 2015. The 2024 varieties are marked as bred abroad,
and the 4 announced varieties are replaced by the 2 in release process in 2026.

Co-Authored-By: Claude Opus 5.5 <noreply@anthropic.com>
Claude-Session: https://claude.ai/code/session_01GCSUFXh2mYdWNgg7VCeE1G
</commit_message>
<xml_diff>
--- a/research/honduras/slides/Honduras_price_finance_varieties.pptx
+++ b/research/honduras/slides/Honduras_price_finance_varieties.pptx
@@ -7174,7 +7174,7 @@
                 <a:latin typeface="Arial"/>
                 <a:cs typeface="Arial"/>
               </a:rPr>
-              <a:t>Only 3 rust-resistant varieties from 1990 to 2004, then none until 2024; Lempira broke in 2017</a:t>
+              <a:t>IHCAFE bred 3 rust-resistant varieties (1990–2004), none new until 2024; Lempira failed by 2017</a:t>
             </a:r>
           </a:p>
         </p:txBody>
@@ -7225,7 +7225,7 @@
                 <a:latin typeface="Arial"/>
                 <a:cs typeface="Arial"/>
               </a:rPr>
-              <a:t>IHCAFE 90 (1990s), Lempira (1997–98), Parainema (2004), all with Timor Hybrid resistance; next: 3 varieties in Feb 2024 (Ihcatú 75, Anacafé 14, Obatá), 4 announced</a:t>
+              <a:t>IHCAFE 90 (1990s), Lempira (1997–98 ⚠), Parainema (2004 ⚠), all with Timor Hybrid resistance. Feb 2024: Ihcatú 75, Anacafé 14, Obatá, bred abroad, released by IHCAFE ⚠</a:t>
             </a:r>
           </a:p>
           <a:p>
@@ -7250,7 +7250,7 @@
                 <a:latin typeface="Arial"/>
                 <a:cs typeface="Arial"/>
               </a:rPr>
-              <a:t>Use: 50 % of the area resistant in 2013, 60 % of producers and 62 % of farms in 2014. Then Lempira broke (April 2017); 4 new rust strains in 2018, 16 in 2019</a:t>
+              <a:t>Planted: 50 % of the AREA resistant in 2013, 60 % of PRODUCERS in 2014 (two measures, not a trend). Lempira weakened from 2015 ⚠, loss confirmed April 2017</a:t>
             </a:r>
           </a:p>
           <a:p>
@@ -7275,7 +7275,7 @@
                 <a:latin typeface="Arial"/>
                 <a:cs typeface="Arial"/>
               </a:rPr>
-              <a:t>Productivity: no official yield by variety found. PAPP replanting aimed at 5 → 45 qq/manzana; USDA 2025–26 credits Parainema for the area growth</a:t>
+              <a:t>After Lempira: ≈ 17 % of monitored farms kept a resistant variety (IHCAFE, Oct 2017 ⚠). Parainema last called resistant in May 2021 (USDA). No yield by variety found</a:t>
             </a:r>
           </a:p>
         </p:txBody>
@@ -7978,7 +7978,7 @@
         <p:spPr>
           <a:xfrm>
             <a:off x="2521634" y="2350008"/>
-            <a:ext cx="4079631" cy="182880"/>
+            <a:ext cx="3840480" cy="182880"/>
           </a:xfrm>
           <a:prstGeom prst="rect">
             <a:avLst/>
@@ -7999,14 +7999,14 @@
         </p:nvSpPr>
         <p:spPr>
           <a:xfrm>
-            <a:off x="6601265" y="2350008"/>
-            <a:ext cx="1083212" cy="182880"/>
-          </a:xfrm>
-          <a:prstGeom prst="rect">
-            <a:avLst/>
-          </a:prstGeom>
-          <a:solidFill>
-            <a:srgbClr val="BFBFBF"/>
+            <a:off x="6362114" y="2350008"/>
+            <a:ext cx="1322363" cy="182880"/>
+          </a:xfrm>
+          <a:prstGeom prst="rect">
+            <a:avLst/>
+          </a:prstGeom>
+          <a:solidFill>
+            <a:srgbClr val="ED7D31"/>
           </a:solidFill>
           <a:ln>
             <a:noFill/>
@@ -8069,7 +8069,7 @@
         <p:spPr>
           <a:xfrm>
             <a:off x="2521634" y="2139696"/>
-            <a:ext cx="2926080" cy="182880"/>
+            <a:ext cx="3108960" cy="182880"/>
           </a:xfrm>
           <a:prstGeom prst="rect">
             <a:avLst/>
@@ -8102,7 +8102,7 @@
                 <a:latin typeface="Arial"/>
                 <a:cs typeface="Arial"/>
               </a:rPr>
-              <a:t>resistant in 2018; not listed as resistant in 2020</a:t>
+              <a:t>resistant per IHCAFE in 2018; ~80 % vs the new strain (2017 ⚠)</a:t>
             </a:r>
           </a:p>
         </p:txBody>
@@ -8184,7 +8184,7 @@
         <p:spPr>
           <a:xfrm>
             <a:off x="3647049" y="2990088"/>
-            <a:ext cx="2715065" cy="182880"/>
+            <a:ext cx="2391508" cy="182880"/>
           </a:xfrm>
           <a:prstGeom prst="rect">
             <a:avLst/>
@@ -8205,6 +8205,28 @@
         </p:nvSpPr>
         <p:spPr>
           <a:xfrm>
+            <a:off x="6038557" y="2990088"/>
+            <a:ext cx="323557" cy="182880"/>
+          </a:xfrm>
+          <a:prstGeom prst="rect">
+            <a:avLst/>
+          </a:prstGeom>
+          <a:solidFill>
+            <a:srgbClr val="ED7D31"/>
+          </a:solidFill>
+          <a:ln>
+            <a:noFill/>
+          </a:ln>
+        </p:spPr>
+      </p:sp>
+      <p:sp>
+        <p:nvSpPr>
+          <p:cNvPr id="31" name="Shape 31"/>
+          <p:cNvSpPr/>
+          <p:nvPr/>
+        </p:nvSpPr>
+        <p:spPr>
+          <a:xfrm>
             <a:off x="6362114" y="2990088"/>
             <a:ext cx="1322363" cy="182880"/>
           </a:xfrm>
@@ -8221,7 +8243,7 @@
       </p:sp>
       <p:sp>
         <p:nvSpPr>
-          <p:cNvPr id="31" name="TextBox 31"/>
+          <p:cNvPr id="32" name="TextBox 32"/>
           <p:cNvSpPr txBox="1"/>
           <p:nvPr/>
         </p:nvSpPr>
@@ -8261,21 +8283,21 @@
                 <a:latin typeface="Arial"/>
                 <a:cs typeface="Arial"/>
               </a:rPr>
-              <a:t>1997–98</a:t>
-            </a:r>
-          </a:p>
-        </p:txBody>
-      </p:sp>
-      <p:sp>
-        <p:nvSpPr>
-          <p:cNvPr id="32" name="TextBox 32"/>
+              <a:t>1997–98 ⚠</a:t>
+            </a:r>
+          </a:p>
+        </p:txBody>
+      </p:sp>
+      <p:sp>
+        <p:nvSpPr>
+          <p:cNvPr id="33" name="TextBox 33"/>
           <p:cNvSpPr txBox="1"/>
           <p:nvPr/>
         </p:nvSpPr>
         <p:spPr>
           <a:xfrm>
             <a:off x="3647049" y="2779776"/>
-            <a:ext cx="2926080" cy="182880"/>
+            <a:ext cx="3108960" cy="182880"/>
           </a:xfrm>
           <a:prstGeom prst="rect">
             <a:avLst/>
@@ -8308,14 +8330,14 @@
                 <a:latin typeface="Arial"/>
                 <a:cs typeface="Arial"/>
               </a:rPr>
-              <a:t>resistance lost, April 2017</a:t>
-            </a:r>
-          </a:p>
-        </p:txBody>
-      </p:sp>
-      <p:sp>
-        <p:nvSpPr>
-          <p:cNvPr id="33" name="TextBox 33"/>
+              <a:t>weakening from 2015 ⚠; loss confirmed April 2017</a:t>
+            </a:r>
+          </a:p>
+        </p:txBody>
+      </p:sp>
+      <p:sp>
+        <p:nvSpPr>
+          <p:cNvPr id="34" name="TextBox 34"/>
           <p:cNvSpPr txBox="1"/>
           <p:nvPr/>
         </p:nvSpPr>
@@ -8383,14 +8405,14 @@
       </p:sp>
       <p:sp>
         <p:nvSpPr>
-          <p:cNvPr id="34" name="Shape 34"/>
+          <p:cNvPr id="35" name="Shape 35"/>
           <p:cNvSpPr/>
           <p:nvPr/>
         </p:nvSpPr>
         <p:spPr>
           <a:xfrm>
             <a:off x="4491111" y="3630168"/>
-            <a:ext cx="3193366" cy="182880"/>
+            <a:ext cx="2447778" cy="182880"/>
           </a:xfrm>
           <a:prstGeom prst="rect">
             <a:avLst/>
@@ -8405,7 +8427,29 @@
       </p:sp>
       <p:sp>
         <p:nvSpPr>
-          <p:cNvPr id="35" name="TextBox 35"/>
+          <p:cNvPr id="36" name="Shape 36"/>
+          <p:cNvSpPr/>
+          <p:nvPr/>
+        </p:nvSpPr>
+        <p:spPr>
+          <a:xfrm>
+            <a:off x="6938889" y="3630168"/>
+            <a:ext cx="745588" cy="182880"/>
+          </a:xfrm>
+          <a:prstGeom prst="rect">
+            <a:avLst/>
+          </a:prstGeom>
+          <a:solidFill>
+            <a:srgbClr val="A9D18E"/>
+          </a:solidFill>
+          <a:ln>
+            <a:noFill/>
+          </a:ln>
+        </p:spPr>
+      </p:sp>
+      <p:sp>
+        <p:nvSpPr>
+          <p:cNvPr id="37" name="TextBox 37"/>
           <p:cNvSpPr txBox="1"/>
           <p:nvPr/>
         </p:nvSpPr>
@@ -8445,21 +8489,21 @@
                 <a:latin typeface="Arial"/>
                 <a:cs typeface="Arial"/>
               </a:rPr>
-              <a:t>2004</a:t>
-            </a:r>
-          </a:p>
-        </p:txBody>
-      </p:sp>
-      <p:sp>
-        <p:nvSpPr>
-          <p:cNvPr id="36" name="TextBox 36"/>
+              <a:t>2004 ⚠</a:t>
+            </a:r>
+          </a:p>
+        </p:txBody>
+      </p:sp>
+      <p:sp>
+        <p:nvSpPr>
+          <p:cNvPr id="38" name="TextBox 38"/>
           <p:cNvSpPr txBox="1"/>
           <p:nvPr/>
         </p:nvSpPr>
         <p:spPr>
           <a:xfrm>
             <a:off x="4491111" y="3419856"/>
-            <a:ext cx="2926080" cy="182880"/>
+            <a:ext cx="3108960" cy="182880"/>
           </a:xfrm>
           <a:prstGeom prst="rect">
             <a:avLst/>
@@ -8492,14 +8536,14 @@
                 <a:latin typeface="Arial"/>
                 <a:cs typeface="Arial"/>
               </a:rPr>
-              <a:t>still resistant (IHCAFE, 2020–21)</a:t>
-            </a:r>
-          </a:p>
-        </p:txBody>
-      </p:sp>
-      <p:sp>
-        <p:nvSpPr>
-          <p:cNvPr id="37" name="TextBox 37"/>
+              <a:t>resistant per IHCAFE until May 2021; not re-confirmed since</a:t>
+            </a:r>
+          </a:p>
+        </p:txBody>
+      </p:sp>
+      <p:sp>
+        <p:nvSpPr>
+          <p:cNvPr id="39" name="TextBox 39"/>
           <p:cNvSpPr txBox="1"/>
           <p:nvPr/>
         </p:nvSpPr>
@@ -8560,14 +8604,14 @@
                 <a:latin typeface="Arial"/>
                 <a:cs typeface="Arial"/>
               </a:rPr>
-              <a:t>3 varieties</a:t>
-            </a:r>
-          </a:p>
-        </p:txBody>
-      </p:sp>
-      <p:sp>
-        <p:nvSpPr>
-          <p:cNvPr id="38" name="Shape 38"/>
+              <a:t>bred in Brazil / Guatemala</a:t>
+            </a:r>
+          </a:p>
+        </p:txBody>
+      </p:sp>
+      <p:sp>
+        <p:nvSpPr>
+          <p:cNvPr id="40" name="Shape 40"/>
           <p:cNvSpPr/>
           <p:nvPr/>
         </p:nvSpPr>
@@ -8589,7 +8633,7 @@
       </p:sp>
       <p:sp>
         <p:nvSpPr>
-          <p:cNvPr id="39" name="TextBox 39"/>
+          <p:cNvPr id="41" name="TextBox 41"/>
           <p:cNvSpPr txBox="1"/>
           <p:nvPr/>
         </p:nvSpPr>
@@ -8629,21 +8673,21 @@
                 <a:latin typeface="Arial"/>
                 <a:cs typeface="Arial"/>
               </a:rPr>
-              <a:t>Feb 2024</a:t>
-            </a:r>
-          </a:p>
-        </p:txBody>
-      </p:sp>
-      <p:sp>
-        <p:nvSpPr>
-          <p:cNvPr id="40" name="TextBox 40"/>
-          <p:cNvSpPr txBox="1"/>
-          <p:nvPr/>
-        </p:nvSpPr>
-        <p:spPr>
-          <a:xfrm>
-            <a:off x="4758397" y="4059936"/>
-            <a:ext cx="2926080" cy="182880"/>
+              <a:t>2024 ⚠</a:t>
+            </a:r>
+          </a:p>
+        </p:txBody>
+      </p:sp>
+      <p:sp>
+        <p:nvSpPr>
+          <p:cNvPr id="42" name="TextBox 42"/>
+          <p:cNvSpPr txBox="1"/>
+          <p:nvPr/>
+        </p:nvSpPr>
+        <p:spPr>
+          <a:xfrm>
+            <a:off x="4575517" y="4059936"/>
+            <a:ext cx="3108960" cy="182880"/>
           </a:xfrm>
           <a:prstGeom prst="rect">
             <a:avLst/>
@@ -8683,7 +8727,7 @@
       </p:sp>
       <p:sp>
         <p:nvSpPr>
-          <p:cNvPr id="41" name="TextBox 41"/>
+          <p:cNvPr id="43" name="TextBox 43"/>
           <p:cNvSpPr txBox="1"/>
           <p:nvPr/>
         </p:nvSpPr>
@@ -8723,7 +8767,7 @@
                 <a:latin typeface="Arial"/>
                 <a:cs typeface="Arial"/>
               </a:rPr>
-              <a:t>4 more varieties</a:t>
+              <a:t>2 more varieties</a:t>
             </a:r>
           </a:p>
           <a:p>
@@ -8744,14 +8788,14 @@
                 <a:latin typeface="Arial"/>
                 <a:cs typeface="Arial"/>
               </a:rPr>
-              <a:t>announced</a:t>
-            </a:r>
-          </a:p>
-        </p:txBody>
-      </p:sp>
-      <p:sp>
-        <p:nvSpPr>
-          <p:cNvPr id="42" name="Shape 42"/>
+              <a:t>in release process</a:t>
+            </a:r>
+          </a:p>
+        </p:txBody>
+      </p:sp>
+      <p:sp>
+        <p:nvSpPr>
+          <p:cNvPr id="44" name="Shape 44"/>
           <p:cNvSpPr/>
           <p:nvPr/>
         </p:nvSpPr>
@@ -8773,14 +8817,14 @@
       </p:sp>
       <p:sp>
         <p:nvSpPr>
-          <p:cNvPr id="43" name="TextBox 43"/>
-          <p:cNvSpPr txBox="1"/>
-          <p:nvPr/>
-        </p:nvSpPr>
-        <p:spPr>
-          <a:xfrm>
-            <a:off x="4758397" y="4700016"/>
-            <a:ext cx="2926080" cy="182880"/>
+          <p:cNvPr id="45" name="TextBox 45"/>
+          <p:cNvSpPr txBox="1"/>
+          <p:nvPr/>
+        </p:nvSpPr>
+        <p:spPr>
+          <a:xfrm>
+            <a:off x="4575517" y="4700016"/>
+            <a:ext cx="3108960" cy="182880"/>
           </a:xfrm>
           <a:prstGeom prst="rect">
             <a:avLst/>
@@ -8813,14 +8857,14 @@
                 <a:latin typeface="Arial"/>
                 <a:cs typeface="Arial"/>
               </a:rPr>
-              <a:t>in preparation ⚠</a:t>
-            </a:r>
-          </a:p>
-        </p:txBody>
-      </p:sp>
-      <p:sp>
-        <p:nvSpPr>
-          <p:cNvPr id="44" name="Shape 44"/>
+              <a:t>announced early 2026 ⚠</a:t>
+            </a:r>
+          </a:p>
+        </p:txBody>
+      </p:sp>
+      <p:sp>
+        <p:nvSpPr>
+          <p:cNvPr id="46" name="Shape 46"/>
           <p:cNvSpPr/>
           <p:nvPr/>
         </p:nvSpPr>
@@ -8842,7 +8886,7 @@
       </p:sp>
       <p:sp>
         <p:nvSpPr>
-          <p:cNvPr id="45" name="Shape 45"/>
+          <p:cNvPr id="47" name="Shape 47"/>
           <p:cNvSpPr/>
           <p:nvPr/>
         </p:nvSpPr>
@@ -8864,7 +8908,7 @@
       </p:sp>
       <p:sp>
         <p:nvSpPr>
-          <p:cNvPr id="46" name="TextBox 46"/>
+          <p:cNvPr id="48" name="TextBox 48"/>
           <p:cNvSpPr txBox="1"/>
           <p:nvPr/>
         </p:nvSpPr>
@@ -8932,89 +8976,20 @@
       </p:sp>
       <p:sp>
         <p:nvSpPr>
-          <p:cNvPr id="47" name="Shape 47"/>
-          <p:cNvSpPr/>
-          <p:nvPr/>
-        </p:nvSpPr>
-        <p:spPr>
-          <a:xfrm>
-            <a:off x="2286000" y="5833872"/>
-            <a:ext cx="164592" cy="128016"/>
-          </a:xfrm>
-          <a:prstGeom prst="rect">
-            <a:avLst/>
-          </a:prstGeom>
-          <a:solidFill>
-            <a:srgbClr val="2E7D32"/>
-          </a:solidFill>
-          <a:ln>
-            <a:noFill/>
-          </a:ln>
-        </p:spPr>
-      </p:sp>
-      <p:sp>
-        <p:nvSpPr>
-          <p:cNvPr id="48" name="TextBox 48"/>
-          <p:cNvSpPr txBox="1"/>
-          <p:nvPr/>
-        </p:nvSpPr>
-        <p:spPr>
-          <a:xfrm>
-            <a:off x="2569464" y="5797296"/>
-            <a:ext cx="2926080" cy="201168"/>
-          </a:xfrm>
-          <a:prstGeom prst="rect">
-            <a:avLst/>
-          </a:prstGeom>
-          <a:noFill/>
-          <a:ln>
-            <a:noFill/>
-          </a:ln>
-        </p:spPr>
-        <p:txBody>
-          <a:bodyPr wrap="square" lIns="0" tIns="0" rIns="0" bIns="0" anchor="t" rtlCol="0">
-            <a:noAutofit/>
-          </a:bodyPr>
-          <a:lstStyle/>
-          <a:p>
-            <a:pPr algn="l" marL="0" indent="0">
-              <a:spcBef>
-                <a:spcPts val="0"/>
-              </a:spcBef>
-              <a:spcAft>
-                <a:spcPts val="0"/>
-              </a:spcAft>
-              <a:buNone/>
-            </a:pPr>
-            <a:r>
-              <a:rPr lang="en-GB" sz="800" dirty="0">
-                <a:solidFill>
-                  <a:srgbClr val="262626"/>
-                </a:solidFill>
-                <a:latin typeface="Arial"/>
-                <a:cs typeface="Arial"/>
-              </a:rPr>
-              <a:t>resistant</a:t>
-            </a:r>
-          </a:p>
-        </p:txBody>
-      </p:sp>
-      <p:sp>
-        <p:nvSpPr>
           <p:cNvPr id="49" name="Shape 49"/>
           <p:cNvSpPr/>
           <p:nvPr/>
         </p:nvSpPr>
         <p:spPr>
           <a:xfrm>
-            <a:off x="3145170" y="5833872"/>
+            <a:off x="640080" y="5833872"/>
             <a:ext cx="164592" cy="128016"/>
           </a:xfrm>
           <a:prstGeom prst="rect">
             <a:avLst/>
           </a:prstGeom>
           <a:solidFill>
-            <a:srgbClr val="C00000"/>
+            <a:srgbClr val="2E7D32"/>
           </a:solidFill>
           <a:ln>
             <a:noFill/>
@@ -9029,7 +9004,7 @@
         </p:nvSpPr>
         <p:spPr>
           <a:xfrm>
-            <a:off x="3428634" y="5797296"/>
+            <a:off x="923544" y="5797296"/>
             <a:ext cx="2926080" cy="201168"/>
           </a:xfrm>
           <a:prstGeom prst="rect">
@@ -9063,7 +9038,7 @@
                 <a:latin typeface="Arial"/>
                 <a:cs typeface="Arial"/>
               </a:rPr>
-              <a:t>resistance broken</a:t>
+              <a:t>resistant</a:t>
             </a:r>
           </a:p>
         </p:txBody>
@@ -9076,13 +9051,220 @@
         </p:nvSpPr>
         <p:spPr>
           <a:xfrm>
-            <a:off x="4402287" y="5833872"/>
+            <a:off x="1499250" y="5833872"/>
             <a:ext cx="164592" cy="128016"/>
           </a:xfrm>
           <a:prstGeom prst="rect">
             <a:avLst/>
           </a:prstGeom>
           <a:solidFill>
+            <a:srgbClr val="ED7D31"/>
+          </a:solidFill>
+          <a:ln>
+            <a:noFill/>
+          </a:ln>
+        </p:spPr>
+      </p:sp>
+      <p:sp>
+        <p:nvSpPr>
+          <p:cNvPr id="52" name="TextBox 52"/>
+          <p:cNvSpPr txBox="1"/>
+          <p:nvPr/>
+        </p:nvSpPr>
+        <p:spPr>
+          <a:xfrm>
+            <a:off x="1782714" y="5797296"/>
+            <a:ext cx="2926080" cy="201168"/>
+          </a:xfrm>
+          <a:prstGeom prst="rect">
+            <a:avLst/>
+          </a:prstGeom>
+          <a:noFill/>
+          <a:ln>
+            <a:noFill/>
+          </a:ln>
+        </p:spPr>
+        <p:txBody>
+          <a:bodyPr wrap="square" lIns="0" tIns="0" rIns="0" bIns="0" anchor="t" rtlCol="0">
+            <a:noAutofit/>
+          </a:bodyPr>
+          <a:lstStyle/>
+          <a:p>
+            <a:pPr algn="l" marL="0" indent="0">
+              <a:spcBef>
+                <a:spcPts val="0"/>
+              </a:spcBef>
+              <a:spcAft>
+                <a:spcPts val="0"/>
+              </a:spcAft>
+              <a:buNone/>
+            </a:pPr>
+            <a:r>
+              <a:rPr lang="en-GB" sz="800" dirty="0">
+                <a:solidFill>
+                  <a:srgbClr val="262626"/>
+                </a:solidFill>
+                <a:latin typeface="Arial"/>
+                <a:cs typeface="Arial"/>
+              </a:rPr>
+              <a:t>weakening / partial</a:t>
+            </a:r>
+          </a:p>
+        </p:txBody>
+      </p:sp>
+      <p:sp>
+        <p:nvSpPr>
+          <p:cNvPr id="53" name="Shape 53"/>
+          <p:cNvSpPr/>
+          <p:nvPr/>
+        </p:nvSpPr>
+        <p:spPr>
+          <a:xfrm>
+            <a:off x="2855854" y="5833872"/>
+            <a:ext cx="164592" cy="128016"/>
+          </a:xfrm>
+          <a:prstGeom prst="rect">
+            <a:avLst/>
+          </a:prstGeom>
+          <a:solidFill>
+            <a:srgbClr val="C00000"/>
+          </a:solidFill>
+          <a:ln>
+            <a:noFill/>
+          </a:ln>
+        </p:spPr>
+      </p:sp>
+      <p:sp>
+        <p:nvSpPr>
+          <p:cNvPr id="54" name="TextBox 54"/>
+          <p:cNvSpPr txBox="1"/>
+          <p:nvPr/>
+        </p:nvSpPr>
+        <p:spPr>
+          <a:xfrm>
+            <a:off x="3139318" y="5797296"/>
+            <a:ext cx="2926080" cy="201168"/>
+          </a:xfrm>
+          <a:prstGeom prst="rect">
+            <a:avLst/>
+          </a:prstGeom>
+          <a:noFill/>
+          <a:ln>
+            <a:noFill/>
+          </a:ln>
+        </p:spPr>
+        <p:txBody>
+          <a:bodyPr wrap="square" lIns="0" tIns="0" rIns="0" bIns="0" anchor="t" rtlCol="0">
+            <a:noAutofit/>
+          </a:bodyPr>
+          <a:lstStyle/>
+          <a:p>
+            <a:pPr algn="l" marL="0" indent="0">
+              <a:spcBef>
+                <a:spcPts val="0"/>
+              </a:spcBef>
+              <a:spcAft>
+                <a:spcPts val="0"/>
+              </a:spcAft>
+              <a:buNone/>
+            </a:pPr>
+            <a:r>
+              <a:rPr lang="en-GB" sz="800" dirty="0">
+                <a:solidFill>
+                  <a:srgbClr val="262626"/>
+                </a:solidFill>
+                <a:latin typeface="Arial"/>
+                <a:cs typeface="Arial"/>
+              </a:rPr>
+              <a:t>broken</a:t>
+            </a:r>
+          </a:p>
+        </p:txBody>
+      </p:sp>
+      <p:sp>
+        <p:nvSpPr>
+          <p:cNvPr id="55" name="Shape 55"/>
+          <p:cNvSpPr/>
+          <p:nvPr/>
+        </p:nvSpPr>
+        <p:spPr>
+          <a:xfrm>
+            <a:off x="3565794" y="5833872"/>
+            <a:ext cx="164592" cy="128016"/>
+          </a:xfrm>
+          <a:prstGeom prst="rect">
+            <a:avLst/>
+          </a:prstGeom>
+          <a:solidFill>
+            <a:srgbClr val="A9D18E"/>
+          </a:solidFill>
+          <a:ln>
+            <a:noFill/>
+          </a:ln>
+        </p:spPr>
+      </p:sp>
+      <p:sp>
+        <p:nvSpPr>
+          <p:cNvPr id="56" name="TextBox 56"/>
+          <p:cNvSpPr txBox="1"/>
+          <p:nvPr/>
+        </p:nvSpPr>
+        <p:spPr>
+          <a:xfrm>
+            <a:off x="3849258" y="5797296"/>
+            <a:ext cx="2926080" cy="201168"/>
+          </a:xfrm>
+          <a:prstGeom prst="rect">
+            <a:avLst/>
+          </a:prstGeom>
+          <a:noFill/>
+          <a:ln>
+            <a:noFill/>
+          </a:ln>
+        </p:spPr>
+        <p:txBody>
+          <a:bodyPr wrap="square" lIns="0" tIns="0" rIns="0" bIns="0" anchor="t" rtlCol="0">
+            <a:noAutofit/>
+          </a:bodyPr>
+          <a:lstStyle/>
+          <a:p>
+            <a:pPr algn="l" marL="0" indent="0">
+              <a:spcBef>
+                <a:spcPts val="0"/>
+              </a:spcBef>
+              <a:spcAft>
+                <a:spcPts val="0"/>
+              </a:spcAft>
+              <a:buNone/>
+            </a:pPr>
+            <a:r>
+              <a:rPr lang="en-GB" sz="800" dirty="0">
+                <a:solidFill>
+                  <a:srgbClr val="262626"/>
+                </a:solidFill>
+                <a:latin typeface="Arial"/>
+                <a:cs typeface="Arial"/>
+              </a:rPr>
+              <a:t>not re-confirmed</a:t>
+            </a:r>
+          </a:p>
+        </p:txBody>
+      </p:sp>
+      <p:sp>
+        <p:nvSpPr>
+          <p:cNvPr id="57" name="Shape 57"/>
+          <p:cNvSpPr/>
+          <p:nvPr/>
+        </p:nvSpPr>
+        <p:spPr>
+          <a:xfrm>
+            <a:off x="4773168" y="5833872"/>
+            <a:ext cx="164592" cy="128016"/>
+          </a:xfrm>
+          <a:prstGeom prst="rect">
+            <a:avLst/>
+          </a:prstGeom>
+          <a:solidFill>
             <a:srgbClr val="BFBFBF"/>
           </a:solidFill>
           <a:ln>
@@ -9092,13 +9274,13 @@
       </p:sp>
       <p:sp>
         <p:nvSpPr>
-          <p:cNvPr id="52" name="TextBox 52"/>
-          <p:cNvSpPr txBox="1"/>
-          <p:nvPr/>
-        </p:nvSpPr>
-        <p:spPr>
-          <a:xfrm>
-            <a:off x="4685751" y="5797296"/>
+          <p:cNvPr id="58" name="TextBox 58"/>
+          <p:cNvSpPr txBox="1"/>
+          <p:nvPr/>
+        </p:nvSpPr>
+        <p:spPr>
+          <a:xfrm>
+            <a:off x="5056632" y="5797296"/>
             <a:ext cx="2926080" cy="201168"/>
           </a:xfrm>
           <a:prstGeom prst="rect">
@@ -9132,14 +9314,14 @@
                 <a:latin typeface="Arial"/>
                 <a:cs typeface="Arial"/>
               </a:rPr>
-              <a:t>not confirmed / pending</a:t>
-            </a:r>
-          </a:p>
-        </p:txBody>
-      </p:sp>
-      <p:sp>
-        <p:nvSpPr>
-          <p:cNvPr id="53" name="TextBox 53"/>
+              <a:t>pending</a:t>
+            </a:r>
+          </a:p>
+        </p:txBody>
+      </p:sp>
+      <p:sp>
+        <p:nvSpPr>
+          <p:cNvPr id="59" name="TextBox 59"/>
           <p:cNvSpPr txBox="1"/>
           <p:nvPr/>
         </p:nvSpPr>
@@ -9188,7 +9370,7 @@
       </p:sp>
       <p:sp>
         <p:nvSpPr>
-          <p:cNvPr id="54" name="TextBox 54"/>
+          <p:cNvPr id="60" name="TextBox 60"/>
           <p:cNvSpPr txBox="1"/>
           <p:nvPr/>
         </p:nvSpPr>
@@ -9237,7 +9419,7 @@
       </p:sp>
       <p:sp>
         <p:nvSpPr>
-          <p:cNvPr id="55" name="TextBox 55"/>
+          <p:cNvPr id="61" name="TextBox 61"/>
           <p:cNvSpPr txBox="1"/>
           <p:nvPr/>
         </p:nvSpPr>
@@ -9286,7 +9468,7 @@
       </p:sp>
       <p:sp>
         <p:nvSpPr>
-          <p:cNvPr id="56" name="TextBox 56"/>
+          <p:cNvPr id="62" name="TextBox 62"/>
           <p:cNvSpPr txBox="1"/>
           <p:nvPr/>
         </p:nvSpPr>
@@ -9335,7 +9517,7 @@
       </p:sp>
       <p:sp>
         <p:nvSpPr>
-          <p:cNvPr id="57" name="TextBox 57"/>
+          <p:cNvPr id="63" name="TextBox 63"/>
           <p:cNvSpPr txBox="1"/>
           <p:nvPr/>
         </p:nvSpPr>
@@ -9384,7 +9566,7 @@
       </p:sp>
       <p:sp>
         <p:nvSpPr>
-          <p:cNvPr id="58" name="TextBox 58"/>
+          <p:cNvPr id="64" name="TextBox 64"/>
           <p:cNvSpPr txBox="1"/>
           <p:nvPr/>
         </p:nvSpPr>
@@ -9433,7 +9615,7 @@
       </p:sp>
       <p:sp>
         <p:nvSpPr>
-          <p:cNvPr id="59" name="TextBox 59"/>
+          <p:cNvPr id="65" name="TextBox 65"/>
           <p:cNvSpPr txBox="1"/>
           <p:nvPr/>
         </p:nvSpPr>
@@ -9482,7 +9664,7 @@
       </p:sp>
       <p:sp>
         <p:nvSpPr>
-          <p:cNvPr id="60" name="TextBox 60"/>
+          <p:cNvPr id="66" name="TextBox 66"/>
           <p:cNvSpPr txBox="1"/>
           <p:nvPr/>
         </p:nvSpPr>
@@ -9531,7 +9713,7 @@
       </p:sp>
       <p:sp>
         <p:nvSpPr>
-          <p:cNvPr id="61" name="TextBox 61"/>
+          <p:cNvPr id="67" name="TextBox 67"/>
           <p:cNvSpPr txBox="1"/>
           <p:nvPr/>
         </p:nvSpPr>
@@ -9580,7 +9762,7 @@
       </p:sp>
       <p:sp>
         <p:nvSpPr>
-          <p:cNvPr id="62" name="TextBox 62"/>
+          <p:cNvPr id="68" name="TextBox 68"/>
           <p:cNvSpPr txBox="1"/>
           <p:nvPr/>
         </p:nvSpPr>
@@ -9629,7 +9811,7 @@
       </p:sp>
       <p:sp>
         <p:nvSpPr>
-          <p:cNvPr id="63" name="TextBox 63"/>
+          <p:cNvPr id="69" name="TextBox 69"/>
           <p:cNvSpPr txBox="1"/>
           <p:nvPr/>
         </p:nvSpPr>
@@ -9678,7 +9860,7 @@
       </p:sp>
       <p:sp>
         <p:nvSpPr>
-          <p:cNvPr id="64" name="TextBox 64"/>
+          <p:cNvPr id="70" name="TextBox 70"/>
           <p:cNvSpPr txBox="1"/>
           <p:nvPr/>
         </p:nvSpPr>
@@ -9727,7 +9909,7 @@
       </p:sp>
       <p:sp>
         <p:nvSpPr>
-          <p:cNvPr id="65" name="TextBox 65"/>
+          <p:cNvPr id="71" name="TextBox 71"/>
           <p:cNvSpPr txBox="1"/>
           <p:nvPr/>
         </p:nvSpPr>
@@ -9776,7 +9958,7 @@
       </p:sp>
       <p:sp>
         <p:nvSpPr>
-          <p:cNvPr id="66" name="TextBox 66"/>
+          <p:cNvPr id="72" name="TextBox 72"/>
           <p:cNvSpPr txBox="1"/>
           <p:nvPr/>
         </p:nvSpPr>
@@ -9825,7 +10007,7 @@
       </p:sp>
       <p:sp>
         <p:nvSpPr>
-          <p:cNvPr id="67" name="TextBox 67"/>
+          <p:cNvPr id="73" name="TextBox 73"/>
           <p:cNvSpPr txBox="1"/>
           <p:nvPr/>
         </p:nvSpPr>
@@ -9874,7 +10056,7 @@
       </p:sp>
       <p:sp>
         <p:nvSpPr>
-          <p:cNvPr id="68" name="TextBox 68"/>
+          <p:cNvPr id="74" name="TextBox 74"/>
           <p:cNvSpPr txBox="1"/>
           <p:nvPr/>
         </p:nvSpPr>
@@ -9923,7 +10105,7 @@
       </p:sp>
       <p:sp>
         <p:nvSpPr>
-          <p:cNvPr id="69" name="TextBox 69"/>
+          <p:cNvPr id="75" name="TextBox 75"/>
           <p:cNvSpPr txBox="1"/>
           <p:nvPr/>
         </p:nvSpPr>
@@ -9972,7 +10154,7 @@
       </p:sp>
       <p:sp>
         <p:nvSpPr>
-          <p:cNvPr id="70" name="TextBox 70"/>
+          <p:cNvPr id="76" name="TextBox 76"/>
           <p:cNvSpPr txBox="1"/>
           <p:nvPr/>
         </p:nvSpPr>
@@ -10021,7 +10203,7 @@
       </p:sp>
       <p:sp>
         <p:nvSpPr>
-          <p:cNvPr id="71" name="TextBox 71"/>
+          <p:cNvPr id="77" name="TextBox 77"/>
           <p:cNvSpPr txBox="1"/>
           <p:nvPr/>
         </p:nvSpPr>
@@ -10070,7 +10252,7 @@
       </p:sp>
       <p:sp>
         <p:nvSpPr>
-          <p:cNvPr id="72" name="TextBox 72"/>
+          <p:cNvPr id="78" name="TextBox 78"/>
           <p:cNvSpPr txBox="1"/>
           <p:nvPr/>
         </p:nvSpPr>
@@ -10112,14 +10294,14 @@
                 <a:latin typeface="Arial"/>
                 <a:cs typeface="Arial"/>
               </a:rPr>
-              <a:t>Lempira alone = 56,08 % of sampled farms</a:t>
-            </a:r>
-          </a:p>
-        </p:txBody>
-      </p:sp>
-      <p:sp>
-        <p:nvSpPr>
-          <p:cNvPr id="73" name="TextBox 73"/>
+              <a:t>Lempira = 56 % of monitored farms → still resistant ≈ 17 %</a:t>
+            </a:r>
+          </a:p>
+        </p:txBody>
+      </p:sp>
+      <p:sp>
+        <p:nvSpPr>
+          <p:cNvPr id="79" name="TextBox 79"/>
           <p:cNvSpPr txBox="1"/>
           <p:nvPr/>
         </p:nvSpPr>
@@ -10168,7 +10350,7 @@
       </p:sp>
       <p:sp>
         <p:nvSpPr>
-          <p:cNvPr id="74" name="TextBox 74"/>
+          <p:cNvPr id="80" name="TextBox 80"/>
           <p:cNvSpPr txBox="1"/>
           <p:nvPr/>
         </p:nvSpPr>
@@ -10217,7 +10399,7 @@
       </p:sp>
       <p:sp>
         <p:nvSpPr>
-          <p:cNvPr id="75" name="TextBox 75"/>
+          <p:cNvPr id="81" name="TextBox 81"/>
           <p:cNvSpPr txBox="1"/>
           <p:nvPr/>
         </p:nvSpPr>
@@ -10266,7 +10448,7 @@
       </p:sp>
       <p:sp>
         <p:nvSpPr>
-          <p:cNvPr id="76" name="TextBox 76"/>
+          <p:cNvPr id="82" name="TextBox 82"/>
           <p:cNvSpPr txBox="1"/>
           <p:nvPr/>
         </p:nvSpPr>
@@ -10315,7 +10497,7 @@
       </p:sp>
       <p:sp>
         <p:nvSpPr>
-          <p:cNvPr id="77" name="TextBox 77"/>
+          <p:cNvPr id="83" name="TextBox 83"/>
           <p:cNvSpPr txBox="1"/>
           <p:nvPr/>
         </p:nvSpPr>
@@ -10355,7 +10537,7 @@
                 <a:latin typeface="Arial"/>
                 <a:cs typeface="Arial"/>
               </a:rPr>
-              <a:t>Count of releases</a:t>
+              <a:t>Count of IHCAFE releases</a:t>
             </a:r>
           </a:p>
           <a:p>
@@ -10376,7 +10558,7 @@
                 <a:latin typeface="Arial"/>
                 <a:cs typeface="Arial"/>
               </a:rPr>
-              <a:t>1990–2004: 3 (IHCAFE 90, Lempira, Parainema)</a:t>
+              <a:t>1990–2004: 3 bred by IHCAFE (IHCAFE 90, Lempira, Parainema)</a:t>
             </a:r>
           </a:p>
           <a:p>
@@ -10397,7 +10579,7 @@
                 <a:latin typeface="Arial"/>
                 <a:cs typeface="Arial"/>
               </a:rPr>
-              <a:t>2005–2023: 0</a:t>
+              <a:t>2005–2023: none found</a:t>
             </a:r>
           </a:p>
           <a:p>
@@ -10418,7 +10600,7 @@
                 <a:latin typeface="Arial"/>
                 <a:cs typeface="Arial"/>
               </a:rPr>
-              <a:t>2024: 3 · announced: 4 more ⚠</a:t>
+              <a:t>2024: 3 bred abroad ⚠ · 2026: 2 in release process ⚠</a:t>
             </a:r>
           </a:p>
           <a:p>
@@ -10439,35 +10621,14 @@
                 <a:latin typeface="Arial"/>
                 <a:cs typeface="Arial"/>
               </a:rPr>
-              <a:t>Still called resistant by IHCAFE in 2020: Parainema only</a:t>
-            </a:r>
-          </a:p>
-          <a:p>
-            <a:pPr algn="l" marL="0" indent="0">
-              <a:spcBef>
-                <a:spcPts val="0"/>
-              </a:spcBef>
-              <a:spcAft>
-                <a:spcPts val="0"/>
-              </a:spcAft>
-              <a:buNone/>
-            </a:pPr>
-            <a:r>
-              <a:rPr lang="en-GB" sz="800" b="1" dirty="0">
-                <a:solidFill>
-                  <a:srgbClr val="C00000"/>
-                </a:solidFill>
-                <a:latin typeface="Arial"/>
-                <a:cs typeface="Arial"/>
-              </a:rPr>
-              <a:t>After Lempira broke: ≈ 3–4 % of the park still resistant ⚠</a:t>
-            </a:r>
-          </a:p>
-        </p:txBody>
-      </p:sp>
-      <p:sp>
-        <p:nvSpPr>
-          <p:cNvPr id="78" name="TextBox 78"/>
+              <a:t>USDA 2020–21 names only Parainema as still resistant</a:t>
+            </a:r>
+          </a:p>
+        </p:txBody>
+      </p:sp>
+      <p:sp>
+        <p:nvSpPr>
+          <p:cNvPr id="84" name="TextBox 84"/>
           <p:cNvSpPr txBox="1"/>
           <p:nvPr/>
         </p:nvSpPr>
@@ -10507,7 +10668,7 @@
                 <a:latin typeface="Arial"/>
                 <a:cs typeface="Arial"/>
               </a:rPr>
-              <a:t>Sources: USDA FAS Coffee Annual Honduras 2013, 2014, 2017, 2018, 2020, 2021, 2025 (resistance status, adoption, strains, PAPP); release years 1997–98 (Lempira) and 2004 (Parainema), the 2024 releases and the 56 % Lempira share (IHCAFE SAT bulletin No 8, Oct 2017) come from web-search extracts (⚠): the IHCAFE, WCR and press pages could not be opened from here.</a:t>
+              <a:t>✔ USDA FAS Coffee Annual Honduras 2013–2025. ⚠ web extracts (pages blocked here): release years; Lempira weakening from 2015 (PROMECAFE 2019); IHCAFE 90 at 80 % (La Prensa 2017); IHCAFE SAT bulletin No 8, Oct 2017: Lempira = 56,08 % of monitored farms and 67,74 % of susceptible ones → susceptible 82,8 %, resistant 17,2 %; 2024 and 2026 releases.</a:t>
             </a:r>
           </a:p>
         </p:txBody>

</xml_diff>

<commit_message>
Check the variety and financing slides against downloaded sources
Release years (IHCAFE 90 1990, Lempira 1998, Parainema 2004), the 65 % share
of the area in resistant varieties since 2012 and each variety's resistance
history now come from the IHCAFE study presented at the 2019 PROMECAFE
symposium, World Coffee Research pages and dated press articles. Lempira is
tolerant from 2002 and susceptible from 2016; IHCAFE 90 is 20 % susceptible
from 2016. The 2024 varieties were bred abroad; the 4 announced in Sep 2023
became the 3 released in Feb 2024. Decree 93-2018 lends L200 per quintal (not
US$25) and the BANHPROVI fund dates from 2018. The 2013 rust credit: L1,715 M
made available at 10 %, only L335 M used by April 2014.

Co-Authored-By: Claude Opus 5.5 <noreply@anthropic.com>
Claude-Session: https://claude.ai/code/session_01GCSUFXh2mYdWNgg7VCeE1G
</commit_message>
<xml_diff>
--- a/research/honduras/slides/Honduras_price_finance_varieties.pptx
+++ b/research/honduras/slides/Honduras_price_finance_varieties.pptx
@@ -1212,7 +1212,7 @@
             <c:bubble3D val="0"/>
             <c:spPr>
               <a:solidFill>
-                <a:srgbClr val="A6A6A6"/>
+                <a:srgbClr val="1F3864"/>
               </a:solidFill>
             </c:spPr>
           </c:dPt>
@@ -1242,7 +1242,7 @@
             <c:bubble3D val="0"/>
             <c:spPr>
               <a:solidFill>
-                <a:srgbClr val="A6A6A6"/>
+                <a:srgbClr val="1F3864"/>
               </a:solidFill>
             </c:spPr>
           </c:dPt>
@@ -1327,7 +1327,7 @@
                   <c:v>77</c:v>
                 </c:pt>
                 <c:pt idx="4">
-                  <c:v>12.2</c:v>
+                  <c:v>12.6</c:v>
                 </c:pt>
                 <c:pt idx="5">
                   <c:v>12</c:v>
@@ -7174,7 +7174,7 @@
                 <a:latin typeface="Arial"/>
                 <a:cs typeface="Arial"/>
               </a:rPr>
-              <a:t>IHCAFE bred 3 rust-resistant varieties (1990–2004), none new until 2024; Lempira failed by 2017</a:t>
+              <a:t>IHCAFE bred 3 rust-resistant varieties (1990–2004), none new until 2024; Lempira failed in 2016</a:t>
             </a:r>
           </a:p>
         </p:txBody>
@@ -7225,7 +7225,7 @@
                 <a:latin typeface="Arial"/>
                 <a:cs typeface="Arial"/>
               </a:rPr>
-              <a:t>IHCAFE 90 (1990s), Lempira (1997–98 ⚠), Parainema (2004 ⚠), all with Timor Hybrid resistance. Feb 2024: Ihcatú 75, Anacafé 14, Obatá, bred abroad, released by IHCAFE ⚠</a:t>
+              <a:t>Released 1990, 1998, 2004 (IHCAFE study 2019 ✔, World Coffee Research ✔). Feb 2024: Ihcatú 75, Anacafé 14, Obatá, bred abroad and released by IHCAFE ✔</a:t>
             </a:r>
           </a:p>
           <a:p>
@@ -7250,7 +7250,7 @@
                 <a:latin typeface="Arial"/>
                 <a:cs typeface="Arial"/>
               </a:rPr>
-              <a:t>Planted: 50 % of the AREA resistant in 2013, 60 % of PRODUCERS in 2014 (two measures, not a trend). Lempira weakened from 2015 ⚠, loss confirmed April 2017</a:t>
+              <a:t>Planted: resistant varieties = 65 % of the area since 2012, mostly Lempira (IHCAFE ✔); USDA: 50 % of the area in 2013, 60 % of producers in 2014</a:t>
             </a:r>
           </a:p>
           <a:p>
@@ -7275,7 +7275,7 @@
                 <a:latin typeface="Arial"/>
                 <a:cs typeface="Arial"/>
               </a:rPr>
-              <a:t>After Lempira: ≈ 17 % of monitored farms kept a resistant variety (IHCAFE, Oct 2017 ⚠). Parainema last called resistant in May 2021 (USDA). No yield by variety found</a:t>
+              <a:t>Lempira: tolerant from 2002, susceptible in 2016, nationwide by 2019 (IHCAFE ✔). IHCAFE 90: 20 % of plants susceptible from 2016. Parainema: resistant to 2019–21</a:t>
             </a:r>
           </a:p>
         </p:txBody>
@@ -7909,7 +7909,7 @@
         </p:nvSpPr>
         <p:spPr>
           <a:xfrm>
-            <a:off x="411480" y="2286000"/>
+            <a:off x="411480" y="2331720"/>
             <a:ext cx="1828800" cy="365760"/>
           </a:xfrm>
           <a:prstGeom prst="rect">
@@ -7977,8 +7977,8 @@
         </p:nvSpPr>
         <p:spPr>
           <a:xfrm>
-            <a:off x="2521634" y="2350008"/>
-            <a:ext cx="3840480" cy="182880"/>
+            <a:off x="2521634" y="2395728"/>
+            <a:ext cx="3657600" cy="182880"/>
           </a:xfrm>
           <a:prstGeom prst="rect">
             <a:avLst/>
@@ -7999,8 +7999,8 @@
         </p:nvSpPr>
         <p:spPr>
           <a:xfrm>
-            <a:off x="6362114" y="2350008"/>
-            <a:ext cx="1322363" cy="182880"/>
+            <a:off x="6179234" y="2395728"/>
+            <a:ext cx="1505243" cy="182880"/>
           </a:xfrm>
           <a:prstGeom prst="rect">
             <a:avLst/>
@@ -8021,7 +8021,7 @@
         </p:nvSpPr>
         <p:spPr>
           <a:xfrm>
-            <a:off x="2018714" y="2551176"/>
+            <a:off x="2018714" y="2596896"/>
             <a:ext cx="1005840" cy="164592"/>
           </a:xfrm>
           <a:prstGeom prst="rect">
@@ -8055,7 +8055,7 @@
                 <a:latin typeface="Arial"/>
                 <a:cs typeface="Arial"/>
               </a:rPr>
-              <a:t>1990s</a:t>
+              <a:t>1990</a:t>
             </a:r>
           </a:p>
         </p:txBody>
@@ -8068,7 +8068,7 @@
         </p:nvSpPr>
         <p:spPr>
           <a:xfrm>
-            <a:off x="2521634" y="2139696"/>
+            <a:off x="2521634" y="2185416"/>
             <a:ext cx="3108960" cy="182880"/>
           </a:xfrm>
           <a:prstGeom prst="rect">
@@ -8102,7 +8102,7 @@
                 <a:latin typeface="Arial"/>
                 <a:cs typeface="Arial"/>
               </a:rPr>
-              <a:t>resistant per IHCAFE in 2018; ~80 % vs the new strain (2017 ⚠)</a:t>
+              <a:t>resistant 1990–2015; ~20 % of plants susceptible from 2016</a:t>
             </a:r>
           </a:p>
         </p:txBody>
@@ -8115,7 +8115,7 @@
         </p:nvSpPr>
         <p:spPr>
           <a:xfrm>
-            <a:off x="411480" y="2926080"/>
+            <a:off x="411480" y="3108960"/>
             <a:ext cx="1828800" cy="365760"/>
           </a:xfrm>
           <a:prstGeom prst="rect">
@@ -8183,8 +8183,8 @@
         </p:nvSpPr>
         <p:spPr>
           <a:xfrm>
-            <a:off x="3647049" y="2990088"/>
-            <a:ext cx="2391508" cy="182880"/>
+            <a:off x="3647049" y="3172968"/>
+            <a:ext cx="562708" cy="182880"/>
           </a:xfrm>
           <a:prstGeom prst="rect">
             <a:avLst/>
@@ -8205,8 +8205,8 @@
         </p:nvSpPr>
         <p:spPr>
           <a:xfrm>
-            <a:off x="6038557" y="2990088"/>
-            <a:ext cx="323557" cy="182880"/>
+            <a:off x="4209757" y="3172968"/>
+            <a:ext cx="1969477" cy="182880"/>
           </a:xfrm>
           <a:prstGeom prst="rect">
             <a:avLst/>
@@ -8227,8 +8227,8 @@
         </p:nvSpPr>
         <p:spPr>
           <a:xfrm>
-            <a:off x="6362114" y="2990088"/>
-            <a:ext cx="1322363" cy="182880"/>
+            <a:off x="6179234" y="3172968"/>
+            <a:ext cx="1505243" cy="182880"/>
           </a:xfrm>
           <a:prstGeom prst="rect">
             <a:avLst/>
@@ -8249,7 +8249,7 @@
         </p:nvSpPr>
         <p:spPr>
           <a:xfrm>
-            <a:off x="3144129" y="3191256"/>
+            <a:off x="3144129" y="3374136"/>
             <a:ext cx="1005840" cy="164592"/>
           </a:xfrm>
           <a:prstGeom prst="rect">
@@ -8283,7 +8283,7 @@
                 <a:latin typeface="Arial"/>
                 <a:cs typeface="Arial"/>
               </a:rPr>
-              <a:t>1997–98 ⚠</a:t>
+              <a:t>1998</a:t>
             </a:r>
           </a:p>
         </p:txBody>
@@ -8296,7 +8296,7 @@
         </p:nvSpPr>
         <p:spPr>
           <a:xfrm>
-            <a:off x="3647049" y="2779776"/>
+            <a:off x="3647049" y="2962656"/>
             <a:ext cx="3108960" cy="182880"/>
           </a:xfrm>
           <a:prstGeom prst="rect">
@@ -8330,7 +8330,7 @@
                 <a:latin typeface="Arial"/>
                 <a:cs typeface="Arial"/>
               </a:rPr>
-              <a:t>weakening from 2015 ⚠; loss confirmed April 2017</a:t>
+              <a:t>tolerant 2002–15 (rust seen from 2007); susceptible 2016</a:t>
             </a:r>
           </a:p>
         </p:txBody>
@@ -8343,7 +8343,7 @@
         </p:nvSpPr>
         <p:spPr>
           <a:xfrm>
-            <a:off x="411480" y="3566160"/>
+            <a:off x="411480" y="3886200"/>
             <a:ext cx="1828800" cy="365760"/>
           </a:xfrm>
           <a:prstGeom prst="rect">
@@ -8411,7 +8411,7 @@
         </p:nvSpPr>
         <p:spPr>
           <a:xfrm>
-            <a:off x="4491111" y="3630168"/>
+            <a:off x="4491111" y="3950208"/>
             <a:ext cx="2447778" cy="182880"/>
           </a:xfrm>
           <a:prstGeom prst="rect">
@@ -8433,7 +8433,7 @@
         </p:nvSpPr>
         <p:spPr>
           <a:xfrm>
-            <a:off x="6938889" y="3630168"/>
+            <a:off x="6938889" y="3950208"/>
             <a:ext cx="745588" cy="182880"/>
           </a:xfrm>
           <a:prstGeom prst="rect">
@@ -8455,7 +8455,7 @@
         </p:nvSpPr>
         <p:spPr>
           <a:xfrm>
-            <a:off x="3988191" y="3831336"/>
+            <a:off x="3988191" y="4151376"/>
             <a:ext cx="1005840" cy="164592"/>
           </a:xfrm>
           <a:prstGeom prst="rect">
@@ -8489,7 +8489,7 @@
                 <a:latin typeface="Arial"/>
                 <a:cs typeface="Arial"/>
               </a:rPr>
-              <a:t>2004 ⚠</a:t>
+              <a:t>2004</a:t>
             </a:r>
           </a:p>
         </p:txBody>
@@ -8502,7 +8502,7 @@
         </p:nvSpPr>
         <p:spPr>
           <a:xfrm>
-            <a:off x="4491111" y="3419856"/>
+            <a:off x="4491111" y="3739896"/>
             <a:ext cx="3108960" cy="182880"/>
           </a:xfrm>
           <a:prstGeom prst="rect">
@@ -8536,7 +8536,7 @@
                 <a:latin typeface="Arial"/>
                 <a:cs typeface="Arial"/>
               </a:rPr>
-              <a:t>resistant per IHCAFE until May 2021; not re-confirmed since</a:t>
+              <a:t>resistant in IHCAFE tests to 2019, per USDA to 2021</a:t>
             </a:r>
           </a:p>
         </p:txBody>
@@ -8549,7 +8549,7 @@
         </p:nvSpPr>
         <p:spPr>
           <a:xfrm>
-            <a:off x="411480" y="4206240"/>
+            <a:off x="411480" y="4663440"/>
             <a:ext cx="1828800" cy="365760"/>
           </a:xfrm>
           <a:prstGeom prst="rect">
@@ -8617,8 +8617,8 @@
         </p:nvSpPr>
         <p:spPr>
           <a:xfrm>
-            <a:off x="7318717" y="4270248"/>
-            <a:ext cx="365760" cy="182880"/>
+            <a:off x="7325751" y="4727448"/>
+            <a:ext cx="358726" cy="182880"/>
           </a:xfrm>
           <a:prstGeom prst="rect">
             <a:avLst/>
@@ -8639,7 +8639,7 @@
         </p:nvSpPr>
         <p:spPr>
           <a:xfrm>
-            <a:off x="6801729" y="4471416"/>
+            <a:off x="6801729" y="4928616"/>
             <a:ext cx="1005840" cy="164592"/>
           </a:xfrm>
           <a:prstGeom prst="rect">
@@ -8673,7 +8673,7 @@
                 <a:latin typeface="Arial"/>
                 <a:cs typeface="Arial"/>
               </a:rPr>
-              <a:t>2024 ⚠</a:t>
+              <a:t>Feb 2024</a:t>
             </a:r>
           </a:p>
         </p:txBody>
@@ -8686,7 +8686,7 @@
         </p:nvSpPr>
         <p:spPr>
           <a:xfrm>
-            <a:off x="4575517" y="4059936"/>
+            <a:off x="4575517" y="4517136"/>
             <a:ext cx="3108960" cy="182880"/>
           </a:xfrm>
           <a:prstGeom prst="rect">
@@ -8720,78 +8720,32 @@
                 <a:latin typeface="Arial"/>
                 <a:cs typeface="Arial"/>
               </a:rPr>
-              <a:t>seed for ≥ 1 500 manzanas in 2024 ⚠</a:t>
-            </a:r>
-          </a:p>
-        </p:txBody>
-      </p:sp>
-      <p:sp>
-        <p:nvSpPr>
-          <p:cNvPr id="43" name="TextBox 43"/>
-          <p:cNvSpPr txBox="1"/>
-          <p:nvPr/>
-        </p:nvSpPr>
-        <p:spPr>
-          <a:xfrm>
-            <a:off x="411480" y="4846320"/>
-            <a:ext cx="1828800" cy="365760"/>
-          </a:xfrm>
-          <a:prstGeom prst="rect">
-            <a:avLst/>
-          </a:prstGeom>
-          <a:noFill/>
-          <a:ln>
-            <a:noFill/>
-          </a:ln>
-        </p:spPr>
-        <p:txBody>
-          <a:bodyPr wrap="square" lIns="0" tIns="0" rIns="0" bIns="0" anchor="t" rtlCol="0">
-            <a:noAutofit/>
-          </a:bodyPr>
-          <a:lstStyle/>
-          <a:p>
-            <a:pPr algn="l" marL="0" indent="0">
-              <a:spcBef>
-                <a:spcPts val="0"/>
-              </a:spcBef>
-              <a:spcAft>
-                <a:spcPts val="0"/>
-              </a:spcAft>
-              <a:buNone/>
-            </a:pPr>
-            <a:r>
-              <a:rPr lang="en-GB" sz="850" b="1" dirty="0">
-                <a:solidFill>
-                  <a:srgbClr val="262626"/>
-                </a:solidFill>
-                <a:latin typeface="Arial"/>
-                <a:cs typeface="Arial"/>
-              </a:rPr>
-              <a:t>2 more varieties</a:t>
-            </a:r>
-          </a:p>
-          <a:p>
-            <a:pPr algn="l" marL="0" indent="0">
-              <a:spcBef>
-                <a:spcPts val="0"/>
-              </a:spcBef>
-              <a:spcAft>
-                <a:spcPts val="0"/>
-              </a:spcAft>
-              <a:buNone/>
-            </a:pPr>
-            <a:r>
-              <a:rPr lang="en-GB" sz="750" dirty="0">
-                <a:solidFill>
-                  <a:srgbClr val="7F7F7F"/>
-                </a:solidFill>
-                <a:latin typeface="Arial"/>
-                <a:cs typeface="Arial"/>
-              </a:rPr>
-              <a:t>in release process</a:t>
-            </a:r>
-          </a:p>
-        </p:txBody>
+              <a:t>seed for ≥ 1 500 manzanas in 2024</a:t>
+            </a:r>
+          </a:p>
+        </p:txBody>
+      </p:sp>
+      <p:sp>
+        <p:nvSpPr>
+          <p:cNvPr id="43" name="Shape 43"/>
+          <p:cNvSpPr/>
+          <p:nvPr/>
+        </p:nvSpPr>
+        <p:spPr>
+          <a:xfrm>
+            <a:off x="6497304" y="2148840"/>
+            <a:ext cx="10973" cy="3383280"/>
+          </a:xfrm>
+          <a:prstGeom prst="rect">
+            <a:avLst/>
+          </a:prstGeom>
+          <a:solidFill>
+            <a:srgbClr val="8497B0"/>
+          </a:solidFill>
+          <a:ln>
+            <a:noFill/>
+          </a:ln>
+        </p:spPr>
       </p:sp>
       <p:sp>
         <p:nvSpPr>
@@ -8801,14 +8755,14 @@
         </p:nvSpPr>
         <p:spPr>
           <a:xfrm>
-            <a:off x="7614138" y="4910328"/>
-            <a:ext cx="70338" cy="182880"/>
-          </a:xfrm>
-          <a:prstGeom prst="rect">
-            <a:avLst/>
-          </a:prstGeom>
-          <a:solidFill>
-            <a:srgbClr val="BFBFBF"/>
+            <a:off x="6637981" y="2148840"/>
+            <a:ext cx="10973" cy="3383280"/>
+          </a:xfrm>
+          <a:prstGeom prst="rect">
+            <a:avLst/>
+          </a:prstGeom>
+          <a:solidFill>
+            <a:srgbClr val="8497B0"/>
           </a:solidFill>
           <a:ln>
             <a:noFill/>
@@ -8823,8 +8777,8 @@
         </p:nvSpPr>
         <p:spPr>
           <a:xfrm>
-            <a:off x="4575517" y="4700016"/>
-            <a:ext cx="3108960" cy="182880"/>
+            <a:off x="4902591" y="5138928"/>
+            <a:ext cx="1554480" cy="365760"/>
           </a:xfrm>
           <a:prstGeom prst="rect">
             <a:avLst/>
@@ -8850,14 +8804,35 @@
               <a:buNone/>
             </a:pPr>
             <a:r>
-              <a:rPr lang="en-GB" sz="750" dirty="0">
-                <a:solidFill>
-                  <a:srgbClr val="262626"/>
-                </a:solidFill>
-                <a:latin typeface="Arial"/>
-                <a:cs typeface="Arial"/>
-              </a:rPr>
-              <a:t>announced early 2026 ⚠</a:t>
+              <a:rPr lang="en-GB" sz="750" b="1" dirty="0">
+                <a:solidFill>
+                  <a:srgbClr val="1F3864"/>
+                </a:solidFill>
+                <a:latin typeface="Arial"/>
+                <a:cs typeface="Arial"/>
+              </a:rPr>
+              <a:t>Apr 2018: 4 new strains</a:t>
+            </a:r>
+          </a:p>
+          <a:p>
+            <a:pPr algn="r" marL="0" indent="0">
+              <a:spcBef>
+                <a:spcPts val="0"/>
+              </a:spcBef>
+              <a:spcAft>
+                <a:spcPts val="0"/>
+              </a:spcAft>
+              <a:buNone/>
+            </a:pPr>
+            <a:r>
+              <a:rPr lang="en-GB" sz="750" b="1" dirty="0">
+                <a:solidFill>
+                  <a:srgbClr val="1F3864"/>
+                </a:solidFill>
+                <a:latin typeface="Arial"/>
+                <a:cs typeface="Arial"/>
+              </a:rPr>
+              <a:t>Apr 2019: 16 new strains</a:t>
             </a:r>
           </a:p>
         </p:txBody>
@@ -8870,118 +8845,6 @@
         </p:nvSpPr>
         <p:spPr>
           <a:xfrm>
-            <a:off x="6497304" y="2148840"/>
-            <a:ext cx="10973" cy="3383280"/>
-          </a:xfrm>
-          <a:prstGeom prst="rect">
-            <a:avLst/>
-          </a:prstGeom>
-          <a:solidFill>
-            <a:srgbClr val="8497B0"/>
-          </a:solidFill>
-          <a:ln>
-            <a:noFill/>
-          </a:ln>
-        </p:spPr>
-      </p:sp>
-      <p:sp>
-        <p:nvSpPr>
-          <p:cNvPr id="47" name="Shape 47"/>
-          <p:cNvSpPr/>
-          <p:nvPr/>
-        </p:nvSpPr>
-        <p:spPr>
-          <a:xfrm>
-            <a:off x="6637981" y="2148840"/>
-            <a:ext cx="10973" cy="3383280"/>
-          </a:xfrm>
-          <a:prstGeom prst="rect">
-            <a:avLst/>
-          </a:prstGeom>
-          <a:solidFill>
-            <a:srgbClr val="8497B0"/>
-          </a:solidFill>
-          <a:ln>
-            <a:noFill/>
-          </a:ln>
-        </p:spPr>
-      </p:sp>
-      <p:sp>
-        <p:nvSpPr>
-          <p:cNvPr id="48" name="TextBox 48"/>
-          <p:cNvSpPr txBox="1"/>
-          <p:nvPr/>
-        </p:nvSpPr>
-        <p:spPr>
-          <a:xfrm>
-            <a:off x="4902591" y="5138928"/>
-            <a:ext cx="1554480" cy="365760"/>
-          </a:xfrm>
-          <a:prstGeom prst="rect">
-            <a:avLst/>
-          </a:prstGeom>
-          <a:noFill/>
-          <a:ln>
-            <a:noFill/>
-          </a:ln>
-        </p:spPr>
-        <p:txBody>
-          <a:bodyPr wrap="square" lIns="0" tIns="0" rIns="0" bIns="0" anchor="t" rtlCol="0">
-            <a:noAutofit/>
-          </a:bodyPr>
-          <a:lstStyle/>
-          <a:p>
-            <a:pPr algn="r" marL="0" indent="0">
-              <a:spcBef>
-                <a:spcPts val="0"/>
-              </a:spcBef>
-              <a:spcAft>
-                <a:spcPts val="0"/>
-              </a:spcAft>
-              <a:buNone/>
-            </a:pPr>
-            <a:r>
-              <a:rPr lang="en-GB" sz="750" b="1" dirty="0">
-                <a:solidFill>
-                  <a:srgbClr val="1F3864"/>
-                </a:solidFill>
-                <a:latin typeface="Arial"/>
-                <a:cs typeface="Arial"/>
-              </a:rPr>
-              <a:t>Apr 2018: 4 new strains</a:t>
-            </a:r>
-          </a:p>
-          <a:p>
-            <a:pPr algn="r" marL="0" indent="0">
-              <a:spcBef>
-                <a:spcPts val="0"/>
-              </a:spcBef>
-              <a:spcAft>
-                <a:spcPts val="0"/>
-              </a:spcAft>
-              <a:buNone/>
-            </a:pPr>
-            <a:r>
-              <a:rPr lang="en-GB" sz="750" b="1" dirty="0">
-                <a:solidFill>
-                  <a:srgbClr val="1F3864"/>
-                </a:solidFill>
-                <a:latin typeface="Arial"/>
-                <a:cs typeface="Arial"/>
-              </a:rPr>
-              <a:t>Apr 2019: 16 new strains</a:t>
-            </a:r>
-          </a:p>
-        </p:txBody>
-      </p:sp>
-      <p:sp>
-        <p:nvSpPr>
-          <p:cNvPr id="49" name="Shape 49"/>
-          <p:cNvSpPr/>
-          <p:nvPr/>
-        </p:nvSpPr>
-        <p:spPr>
-          <a:xfrm>
             <a:off x="640080" y="5833872"/>
             <a:ext cx="164592" cy="128016"/>
           </a:xfrm>
@@ -8998,7 +8861,7 @@
       </p:sp>
       <p:sp>
         <p:nvSpPr>
-          <p:cNvPr id="50" name="TextBox 50"/>
+          <p:cNvPr id="47" name="TextBox 47"/>
           <p:cNvSpPr txBox="1"/>
           <p:nvPr/>
         </p:nvSpPr>
@@ -9045,7 +8908,7 @@
       </p:sp>
       <p:sp>
         <p:nvSpPr>
-          <p:cNvPr id="51" name="Shape 51"/>
+          <p:cNvPr id="48" name="Shape 48"/>
           <p:cNvSpPr/>
           <p:nvPr/>
         </p:nvSpPr>
@@ -9067,7 +8930,7 @@
       </p:sp>
       <p:sp>
         <p:nvSpPr>
-          <p:cNvPr id="52" name="TextBox 52"/>
+          <p:cNvPr id="49" name="TextBox 49"/>
           <p:cNvSpPr txBox="1"/>
           <p:nvPr/>
         </p:nvSpPr>
@@ -9107,20 +8970,20 @@
                 <a:latin typeface="Arial"/>
                 <a:cs typeface="Arial"/>
               </a:rPr>
-              <a:t>weakening / partial</a:t>
-            </a:r>
-          </a:p>
-        </p:txBody>
-      </p:sp>
-      <p:sp>
-        <p:nvSpPr>
-          <p:cNvPr id="53" name="Shape 53"/>
+              <a:t>tolerant / partly susceptible</a:t>
+            </a:r>
+          </a:p>
+        </p:txBody>
+      </p:sp>
+      <p:sp>
+        <p:nvSpPr>
+          <p:cNvPr id="50" name="Shape 50"/>
           <p:cNvSpPr/>
           <p:nvPr/>
         </p:nvSpPr>
         <p:spPr>
           <a:xfrm>
-            <a:off x="2855854" y="5833872"/>
+            <a:off x="3353288" y="5833872"/>
             <a:ext cx="164592" cy="128016"/>
           </a:xfrm>
           <a:prstGeom prst="rect">
@@ -9136,25 +8999,143 @@
       </p:sp>
       <p:sp>
         <p:nvSpPr>
+          <p:cNvPr id="51" name="TextBox 51"/>
+          <p:cNvSpPr txBox="1"/>
+          <p:nvPr/>
+        </p:nvSpPr>
+        <p:spPr>
+          <a:xfrm>
+            <a:off x="3636752" y="5797296"/>
+            <a:ext cx="2926080" cy="201168"/>
+          </a:xfrm>
+          <a:prstGeom prst="rect">
+            <a:avLst/>
+          </a:prstGeom>
+          <a:noFill/>
+          <a:ln>
+            <a:noFill/>
+          </a:ln>
+        </p:spPr>
+        <p:txBody>
+          <a:bodyPr wrap="square" lIns="0" tIns="0" rIns="0" bIns="0" anchor="t" rtlCol="0">
+            <a:noAutofit/>
+          </a:bodyPr>
+          <a:lstStyle/>
+          <a:p>
+            <a:pPr algn="l" marL="0" indent="0">
+              <a:spcBef>
+                <a:spcPts val="0"/>
+              </a:spcBef>
+              <a:spcAft>
+                <a:spcPts val="0"/>
+              </a:spcAft>
+              <a:buNone/>
+            </a:pPr>
+            <a:r>
+              <a:rPr lang="en-GB" sz="800" dirty="0">
+                <a:solidFill>
+                  <a:srgbClr val="262626"/>
+                </a:solidFill>
+                <a:latin typeface="Arial"/>
+                <a:cs typeface="Arial"/>
+              </a:rPr>
+              <a:t>susceptible</a:t>
+            </a:r>
+          </a:p>
+        </p:txBody>
+      </p:sp>
+      <p:sp>
+        <p:nvSpPr>
+          <p:cNvPr id="52" name="Shape 52"/>
+          <p:cNvSpPr/>
+          <p:nvPr/>
+        </p:nvSpPr>
+        <p:spPr>
+          <a:xfrm>
+            <a:off x="4311945" y="5833872"/>
+            <a:ext cx="164592" cy="128016"/>
+          </a:xfrm>
+          <a:prstGeom prst="rect">
+            <a:avLst/>
+          </a:prstGeom>
+          <a:solidFill>
+            <a:srgbClr val="A9D18E"/>
+          </a:solidFill>
+          <a:ln>
+            <a:noFill/>
+          </a:ln>
+        </p:spPr>
+      </p:sp>
+      <p:sp>
+        <p:nvSpPr>
+          <p:cNvPr id="53" name="TextBox 53"/>
+          <p:cNvSpPr txBox="1"/>
+          <p:nvPr/>
+        </p:nvSpPr>
+        <p:spPr>
+          <a:xfrm>
+            <a:off x="4595409" y="5797296"/>
+            <a:ext cx="2926080" cy="201168"/>
+          </a:xfrm>
+          <a:prstGeom prst="rect">
+            <a:avLst/>
+          </a:prstGeom>
+          <a:noFill/>
+          <a:ln>
+            <a:noFill/>
+          </a:ln>
+        </p:spPr>
+        <p:txBody>
+          <a:bodyPr wrap="square" lIns="0" tIns="0" rIns="0" bIns="0" anchor="t" rtlCol="0">
+            <a:noAutofit/>
+          </a:bodyPr>
+          <a:lstStyle/>
+          <a:p>
+            <a:pPr algn="l" marL="0" indent="0">
+              <a:spcBef>
+                <a:spcPts val="0"/>
+              </a:spcBef>
+              <a:spcAft>
+                <a:spcPts val="0"/>
+              </a:spcAft>
+              <a:buNone/>
+            </a:pPr>
+            <a:r>
+              <a:rPr lang="en-GB" sz="800" dirty="0">
+                <a:solidFill>
+                  <a:srgbClr val="262626"/>
+                </a:solidFill>
+                <a:latin typeface="Arial"/>
+                <a:cs typeface="Arial"/>
+              </a:rPr>
+              <a:t>no statement after 2021</a:t>
+            </a:r>
+          </a:p>
+        </p:txBody>
+      </p:sp>
+      <p:sp>
+        <p:nvSpPr>
           <p:cNvPr id="54" name="TextBox 54"/>
           <p:cNvSpPr txBox="1"/>
           <p:nvPr/>
         </p:nvSpPr>
         <p:spPr>
           <a:xfrm>
-            <a:off x="3139318" y="5797296"/>
-            <a:ext cx="2926080" cy="201168"/>
-          </a:xfrm>
-          <a:prstGeom prst="rect">
-            <a:avLst/>
-          </a:prstGeom>
-          <a:noFill/>
-          <a:ln>
-            <a:noFill/>
-          </a:ln>
-        </p:spPr>
-        <p:txBody>
-          <a:bodyPr wrap="square" lIns="0" tIns="0" rIns="0" bIns="0" anchor="t" rtlCol="0">
+            <a:off x="8001000" y="1874520"/>
+            <a:ext cx="731520" cy="292608"/>
+          </a:xfrm>
+          <a:prstGeom prst="rect">
+            <a:avLst/>
+          </a:prstGeom>
+          <a:solidFill>
+            <a:srgbClr val="1F3864"/>
+          </a:solidFill>
+          <a:ln>
+            <a:noFill/>
+          </a:ln>
+        </p:spPr>
+        <p:txBody>
+          <a:bodyPr wrap="square" lIns="36576" tIns="27432" rIns="36576" bIns="27432" anchor="ctr" rtlCol="0">
             <a:noAutofit/>
           </a:bodyPr>
           <a:lstStyle/>
@@ -9169,257 +9150,70 @@
               <a:buNone/>
             </a:pPr>
             <a:r>
-              <a:rPr lang="en-GB" sz="800" dirty="0">
-                <a:solidFill>
-                  <a:srgbClr val="262626"/>
-                </a:solidFill>
-                <a:latin typeface="Arial"/>
-                <a:cs typeface="Arial"/>
-              </a:rPr>
-              <a:t>broken</a:t>
-            </a:r>
-          </a:p>
-        </p:txBody>
-      </p:sp>
-      <p:sp>
-        <p:nvSpPr>
-          <p:cNvPr id="55" name="Shape 55"/>
-          <p:cNvSpPr/>
-          <p:nvPr/>
-        </p:nvSpPr>
-        <p:spPr>
-          <a:xfrm>
-            <a:off x="3565794" y="5833872"/>
-            <a:ext cx="164592" cy="128016"/>
-          </a:xfrm>
-          <a:prstGeom prst="rect">
-            <a:avLst/>
-          </a:prstGeom>
-          <a:solidFill>
-            <a:srgbClr val="A9D18E"/>
-          </a:solidFill>
-          <a:ln>
-            <a:noFill/>
-          </a:ln>
-        </p:spPr>
+              <a:rPr lang="en-GB" sz="750" b="1" dirty="0">
+                <a:solidFill>
+                  <a:srgbClr val="FFFFFF"/>
+                </a:solidFill>
+                <a:latin typeface="Arial"/>
+                <a:cs typeface="Arial"/>
+              </a:rPr>
+              <a:t>When</a:t>
+            </a:r>
+          </a:p>
+        </p:txBody>
+      </p:sp>
+      <p:sp>
+        <p:nvSpPr>
+          <p:cNvPr id="55" name="TextBox 55"/>
+          <p:cNvSpPr txBox="1"/>
+          <p:nvPr/>
+        </p:nvSpPr>
+        <p:spPr>
+          <a:xfrm>
+            <a:off x="8732520" y="1874520"/>
+            <a:ext cx="2057400" cy="292608"/>
+          </a:xfrm>
+          <a:prstGeom prst="rect">
+            <a:avLst/>
+          </a:prstGeom>
+          <a:solidFill>
+            <a:srgbClr val="1F3864"/>
+          </a:solidFill>
+          <a:ln>
+            <a:noFill/>
+          </a:ln>
+        </p:spPr>
+        <p:txBody>
+          <a:bodyPr wrap="square" lIns="36576" tIns="27432" rIns="36576" bIns="27432" anchor="ctr" rtlCol="0">
+            <a:noAutofit/>
+          </a:bodyPr>
+          <a:lstStyle/>
+          <a:p>
+            <a:pPr algn="ctr" marL="0" indent="0">
+              <a:spcBef>
+                <a:spcPts val="0"/>
+              </a:spcBef>
+              <a:spcAft>
+                <a:spcPts val="0"/>
+              </a:spcAft>
+              <a:buNone/>
+            </a:pPr>
+            <a:r>
+              <a:rPr lang="en-GB" sz="750" b="1" dirty="0">
+                <a:solidFill>
+                  <a:srgbClr val="FFFFFF"/>
+                </a:solidFill>
+                <a:latin typeface="Arial"/>
+                <a:cs typeface="Arial"/>
+              </a:rPr>
+              <a:t>Share with resistant varieties</a:t>
+            </a:r>
+          </a:p>
+        </p:txBody>
       </p:sp>
       <p:sp>
         <p:nvSpPr>
           <p:cNvPr id="56" name="TextBox 56"/>
-          <p:cNvSpPr txBox="1"/>
-          <p:nvPr/>
-        </p:nvSpPr>
-        <p:spPr>
-          <a:xfrm>
-            <a:off x="3849258" y="5797296"/>
-            <a:ext cx="2926080" cy="201168"/>
-          </a:xfrm>
-          <a:prstGeom prst="rect">
-            <a:avLst/>
-          </a:prstGeom>
-          <a:noFill/>
-          <a:ln>
-            <a:noFill/>
-          </a:ln>
-        </p:spPr>
-        <p:txBody>
-          <a:bodyPr wrap="square" lIns="0" tIns="0" rIns="0" bIns="0" anchor="t" rtlCol="0">
-            <a:noAutofit/>
-          </a:bodyPr>
-          <a:lstStyle/>
-          <a:p>
-            <a:pPr algn="l" marL="0" indent="0">
-              <a:spcBef>
-                <a:spcPts val="0"/>
-              </a:spcBef>
-              <a:spcAft>
-                <a:spcPts val="0"/>
-              </a:spcAft>
-              <a:buNone/>
-            </a:pPr>
-            <a:r>
-              <a:rPr lang="en-GB" sz="800" dirty="0">
-                <a:solidFill>
-                  <a:srgbClr val="262626"/>
-                </a:solidFill>
-                <a:latin typeface="Arial"/>
-                <a:cs typeface="Arial"/>
-              </a:rPr>
-              <a:t>not re-confirmed</a:t>
-            </a:r>
-          </a:p>
-        </p:txBody>
-      </p:sp>
-      <p:sp>
-        <p:nvSpPr>
-          <p:cNvPr id="57" name="Shape 57"/>
-          <p:cNvSpPr/>
-          <p:nvPr/>
-        </p:nvSpPr>
-        <p:spPr>
-          <a:xfrm>
-            <a:off x="4773168" y="5833872"/>
-            <a:ext cx="164592" cy="128016"/>
-          </a:xfrm>
-          <a:prstGeom prst="rect">
-            <a:avLst/>
-          </a:prstGeom>
-          <a:solidFill>
-            <a:srgbClr val="BFBFBF"/>
-          </a:solidFill>
-          <a:ln>
-            <a:noFill/>
-          </a:ln>
-        </p:spPr>
-      </p:sp>
-      <p:sp>
-        <p:nvSpPr>
-          <p:cNvPr id="58" name="TextBox 58"/>
-          <p:cNvSpPr txBox="1"/>
-          <p:nvPr/>
-        </p:nvSpPr>
-        <p:spPr>
-          <a:xfrm>
-            <a:off x="5056632" y="5797296"/>
-            <a:ext cx="2926080" cy="201168"/>
-          </a:xfrm>
-          <a:prstGeom prst="rect">
-            <a:avLst/>
-          </a:prstGeom>
-          <a:noFill/>
-          <a:ln>
-            <a:noFill/>
-          </a:ln>
-        </p:spPr>
-        <p:txBody>
-          <a:bodyPr wrap="square" lIns="0" tIns="0" rIns="0" bIns="0" anchor="t" rtlCol="0">
-            <a:noAutofit/>
-          </a:bodyPr>
-          <a:lstStyle/>
-          <a:p>
-            <a:pPr algn="l" marL="0" indent="0">
-              <a:spcBef>
-                <a:spcPts val="0"/>
-              </a:spcBef>
-              <a:spcAft>
-                <a:spcPts val="0"/>
-              </a:spcAft>
-              <a:buNone/>
-            </a:pPr>
-            <a:r>
-              <a:rPr lang="en-GB" sz="800" dirty="0">
-                <a:solidFill>
-                  <a:srgbClr val="262626"/>
-                </a:solidFill>
-                <a:latin typeface="Arial"/>
-                <a:cs typeface="Arial"/>
-              </a:rPr>
-              <a:t>pending</a:t>
-            </a:r>
-          </a:p>
-        </p:txBody>
-      </p:sp>
-      <p:sp>
-        <p:nvSpPr>
-          <p:cNvPr id="59" name="TextBox 59"/>
-          <p:cNvSpPr txBox="1"/>
-          <p:nvPr/>
-        </p:nvSpPr>
-        <p:spPr>
-          <a:xfrm>
-            <a:off x="8001000" y="1874520"/>
-            <a:ext cx="685800" cy="292608"/>
-          </a:xfrm>
-          <a:prstGeom prst="rect">
-            <a:avLst/>
-          </a:prstGeom>
-          <a:solidFill>
-            <a:srgbClr val="1F3864"/>
-          </a:solidFill>
-          <a:ln>
-            <a:noFill/>
-          </a:ln>
-        </p:spPr>
-        <p:txBody>
-          <a:bodyPr wrap="square" lIns="36576" tIns="27432" rIns="36576" bIns="27432" anchor="ctr" rtlCol="0">
-            <a:noAutofit/>
-          </a:bodyPr>
-          <a:lstStyle/>
-          <a:p>
-            <a:pPr algn="l" marL="0" indent="0">
-              <a:spcBef>
-                <a:spcPts val="0"/>
-              </a:spcBef>
-              <a:spcAft>
-                <a:spcPts val="0"/>
-              </a:spcAft>
-              <a:buNone/>
-            </a:pPr>
-            <a:r>
-              <a:rPr lang="en-GB" sz="750" b="1" dirty="0">
-                <a:solidFill>
-                  <a:srgbClr val="FFFFFF"/>
-                </a:solidFill>
-                <a:latin typeface="Arial"/>
-                <a:cs typeface="Arial"/>
-              </a:rPr>
-              <a:t>When</a:t>
-            </a:r>
-          </a:p>
-        </p:txBody>
-      </p:sp>
-      <p:sp>
-        <p:nvSpPr>
-          <p:cNvPr id="60" name="TextBox 60"/>
-          <p:cNvSpPr txBox="1"/>
-          <p:nvPr/>
-        </p:nvSpPr>
-        <p:spPr>
-          <a:xfrm>
-            <a:off x="8686800" y="1874520"/>
-            <a:ext cx="2103120" cy="292608"/>
-          </a:xfrm>
-          <a:prstGeom prst="rect">
-            <a:avLst/>
-          </a:prstGeom>
-          <a:solidFill>
-            <a:srgbClr val="1F3864"/>
-          </a:solidFill>
-          <a:ln>
-            <a:noFill/>
-          </a:ln>
-        </p:spPr>
-        <p:txBody>
-          <a:bodyPr wrap="square" lIns="36576" tIns="27432" rIns="36576" bIns="27432" anchor="ctr" rtlCol="0">
-            <a:noAutofit/>
-          </a:bodyPr>
-          <a:lstStyle/>
-          <a:p>
-            <a:pPr algn="ctr" marL="0" indent="0">
-              <a:spcBef>
-                <a:spcPts val="0"/>
-              </a:spcBef>
-              <a:spcAft>
-                <a:spcPts val="0"/>
-              </a:spcAft>
-              <a:buNone/>
-            </a:pPr>
-            <a:r>
-              <a:rPr lang="en-GB" sz="750" b="1" dirty="0">
-                <a:solidFill>
-                  <a:srgbClr val="FFFFFF"/>
-                </a:solidFill>
-                <a:latin typeface="Arial"/>
-                <a:cs typeface="Arial"/>
-              </a:rPr>
-              <a:t>Share with resistant varieties</a:t>
-            </a:r>
-          </a:p>
-        </p:txBody>
-      </p:sp>
-      <p:sp>
-        <p:nvSpPr>
-          <p:cNvPr id="61" name="TextBox 61"/>
           <p:cNvSpPr txBox="1"/>
           <p:nvPr/>
         </p:nvSpPr>
@@ -9468,14 +9262,14 @@
       </p:sp>
       <p:sp>
         <p:nvSpPr>
-          <p:cNvPr id="62" name="TextBox 62"/>
+          <p:cNvPr id="57" name="TextBox 57"/>
           <p:cNvSpPr txBox="1"/>
           <p:nvPr/>
         </p:nvSpPr>
         <p:spPr>
           <a:xfrm>
             <a:off x="8001000" y="2167128"/>
-            <a:ext cx="685800" cy="365760"/>
+            <a:ext cx="731520" cy="365760"/>
           </a:xfrm>
           <a:prstGeom prst="rect">
             <a:avLst/>
@@ -9517,14 +9311,14 @@
       </p:sp>
       <p:sp>
         <p:nvSpPr>
-          <p:cNvPr id="63" name="TextBox 63"/>
-          <p:cNvSpPr txBox="1"/>
-          <p:nvPr/>
-        </p:nvSpPr>
-        <p:spPr>
-          <a:xfrm>
-            <a:off x="8686800" y="2167128"/>
-            <a:ext cx="2103120" cy="365760"/>
+          <p:cNvPr id="58" name="TextBox 58"/>
+          <p:cNvSpPr txBox="1"/>
+          <p:nvPr/>
+        </p:nvSpPr>
+        <p:spPr>
+          <a:xfrm>
+            <a:off x="8732520" y="2167128"/>
+            <a:ext cx="2057400" cy="365760"/>
           </a:xfrm>
           <a:prstGeom prst="rect">
             <a:avLst/>
@@ -9566,7 +9360,7 @@
       </p:sp>
       <p:sp>
         <p:nvSpPr>
-          <p:cNvPr id="64" name="TextBox 64"/>
+          <p:cNvPr id="59" name="TextBox 59"/>
           <p:cNvSpPr txBox="1"/>
           <p:nvPr/>
         </p:nvSpPr>
@@ -9615,14 +9409,14 @@
       </p:sp>
       <p:sp>
         <p:nvSpPr>
-          <p:cNvPr id="65" name="TextBox 65"/>
+          <p:cNvPr id="60" name="TextBox 60"/>
           <p:cNvSpPr txBox="1"/>
           <p:nvPr/>
         </p:nvSpPr>
         <p:spPr>
           <a:xfrm>
             <a:off x="8001000" y="2532888"/>
-            <a:ext cx="685800" cy="365760"/>
+            <a:ext cx="731520" cy="365760"/>
           </a:xfrm>
           <a:prstGeom prst="rect">
             <a:avLst/>
@@ -9657,21 +9451,21 @@
                 <a:latin typeface="Arial"/>
                 <a:cs typeface="Arial"/>
               </a:rPr>
-              <a:t>2013</a:t>
-            </a:r>
-          </a:p>
-        </p:txBody>
-      </p:sp>
-      <p:sp>
-        <p:nvSpPr>
-          <p:cNvPr id="66" name="TextBox 66"/>
-          <p:cNvSpPr txBox="1"/>
-          <p:nvPr/>
-        </p:nvSpPr>
-        <p:spPr>
-          <a:xfrm>
-            <a:off x="8686800" y="2532888"/>
-            <a:ext cx="2103120" cy="365760"/>
+              <a:t>since 2012</a:t>
+            </a:r>
+          </a:p>
+        </p:txBody>
+      </p:sp>
+      <p:sp>
+        <p:nvSpPr>
+          <p:cNvPr id="61" name="TextBox 61"/>
+          <p:cNvSpPr txBox="1"/>
+          <p:nvPr/>
+        </p:nvSpPr>
+        <p:spPr>
+          <a:xfrm>
+            <a:off x="8732520" y="2532888"/>
+            <a:ext cx="2057400" cy="365760"/>
           </a:xfrm>
           <a:prstGeom prst="rect">
             <a:avLst/>
@@ -9706,14 +9500,14 @@
                 <a:latin typeface="Arial"/>
                 <a:cs typeface="Arial"/>
               </a:rPr>
-              <a:t>50 % (200 000 of 400 000 manzanas)</a:t>
-            </a:r>
-          </a:p>
-        </p:txBody>
-      </p:sp>
-      <p:sp>
-        <p:nvSpPr>
-          <p:cNvPr id="67" name="TextBox 67"/>
+              <a:t>65 % of the area, mostly Lempira</a:t>
+            </a:r>
+          </a:p>
+        </p:txBody>
+      </p:sp>
+      <p:sp>
+        <p:nvSpPr>
+          <p:cNvPr id="62" name="TextBox 62"/>
           <p:cNvSpPr txBox="1"/>
           <p:nvPr/>
         </p:nvSpPr>
@@ -9755,21 +9549,21 @@
                 <a:latin typeface="Arial"/>
                 <a:cs typeface="Arial"/>
               </a:rPr>
-              <a:t>⚠ El Heraldo 2013</a:t>
-            </a:r>
-          </a:p>
-        </p:txBody>
-      </p:sp>
-      <p:sp>
-        <p:nvSpPr>
-          <p:cNvPr id="68" name="TextBox 68"/>
+              <a:t>✔ Morales &amp; Grajeda</a:t>
+            </a:r>
+          </a:p>
+        </p:txBody>
+      </p:sp>
+      <p:sp>
+        <p:nvSpPr>
+          <p:cNvPr id="63" name="TextBox 63"/>
           <p:cNvSpPr txBox="1"/>
           <p:nvPr/>
         </p:nvSpPr>
         <p:spPr>
           <a:xfrm>
             <a:off x="8001000" y="2898648"/>
-            <a:ext cx="685800" cy="365760"/>
+            <a:ext cx="731520" cy="365760"/>
           </a:xfrm>
           <a:prstGeom prst="rect">
             <a:avLst/>
@@ -9811,14 +9605,14 @@
       </p:sp>
       <p:sp>
         <p:nvSpPr>
-          <p:cNvPr id="69" name="TextBox 69"/>
-          <p:cNvSpPr txBox="1"/>
-          <p:nvPr/>
-        </p:nvSpPr>
-        <p:spPr>
-          <a:xfrm>
-            <a:off x="8686800" y="2898648"/>
-            <a:ext cx="2103120" cy="365760"/>
+          <p:cNvPr id="64" name="TextBox 64"/>
+          <p:cNvSpPr txBox="1"/>
+          <p:nvPr/>
+        </p:nvSpPr>
+        <p:spPr>
+          <a:xfrm>
+            <a:off x="8732520" y="2898648"/>
+            <a:ext cx="2057400" cy="365760"/>
           </a:xfrm>
           <a:prstGeom prst="rect">
             <a:avLst/>
@@ -9860,7 +9654,7 @@
       </p:sp>
       <p:sp>
         <p:nvSpPr>
-          <p:cNvPr id="70" name="TextBox 70"/>
+          <p:cNvPr id="65" name="TextBox 65"/>
           <p:cNvSpPr txBox="1"/>
           <p:nvPr/>
         </p:nvSpPr>
@@ -9909,14 +9703,14 @@
       </p:sp>
       <p:sp>
         <p:nvSpPr>
-          <p:cNvPr id="71" name="TextBox 71"/>
+          <p:cNvPr id="66" name="TextBox 66"/>
           <p:cNvSpPr txBox="1"/>
           <p:nvPr/>
         </p:nvSpPr>
         <p:spPr>
           <a:xfrm>
             <a:off x="8001000" y="3264408"/>
-            <a:ext cx="685800" cy="365760"/>
+            <a:ext cx="731520" cy="365760"/>
           </a:xfrm>
           <a:prstGeom prst="rect">
             <a:avLst/>
@@ -9958,14 +9752,14 @@
       </p:sp>
       <p:sp>
         <p:nvSpPr>
-          <p:cNvPr id="72" name="TextBox 72"/>
-          <p:cNvSpPr txBox="1"/>
-          <p:nvPr/>
-        </p:nvSpPr>
-        <p:spPr>
-          <a:xfrm>
-            <a:off x="8686800" y="3264408"/>
-            <a:ext cx="2103120" cy="365760"/>
+          <p:cNvPr id="67" name="TextBox 67"/>
+          <p:cNvSpPr txBox="1"/>
+          <p:nvPr/>
+        </p:nvSpPr>
+        <p:spPr>
+          <a:xfrm>
+            <a:off x="8732520" y="3264408"/>
+            <a:ext cx="2057400" cy="365760"/>
           </a:xfrm>
           <a:prstGeom prst="rect">
             <a:avLst/>
@@ -10007,7 +9801,7 @@
       </p:sp>
       <p:sp>
         <p:nvSpPr>
-          <p:cNvPr id="73" name="TextBox 73"/>
+          <p:cNvPr id="68" name="TextBox 68"/>
           <p:cNvSpPr txBox="1"/>
           <p:nvPr/>
         </p:nvSpPr>
@@ -10056,14 +9850,14 @@
       </p:sp>
       <p:sp>
         <p:nvSpPr>
-          <p:cNvPr id="74" name="TextBox 74"/>
+          <p:cNvPr id="69" name="TextBox 69"/>
           <p:cNvSpPr txBox="1"/>
           <p:nvPr/>
         </p:nvSpPr>
         <p:spPr>
           <a:xfrm>
             <a:off x="8001000" y="3630168"/>
-            <a:ext cx="685800" cy="365760"/>
+            <a:ext cx="731520" cy="365760"/>
           </a:xfrm>
           <a:prstGeom prst="rect">
             <a:avLst/>
@@ -10105,14 +9899,14 @@
       </p:sp>
       <p:sp>
         <p:nvSpPr>
-          <p:cNvPr id="75" name="TextBox 75"/>
-          <p:cNvSpPr txBox="1"/>
-          <p:nvPr/>
-        </p:nvSpPr>
-        <p:spPr>
-          <a:xfrm>
-            <a:off x="8686800" y="3630168"/>
-            <a:ext cx="2103120" cy="365760"/>
+          <p:cNvPr id="70" name="TextBox 70"/>
+          <p:cNvSpPr txBox="1"/>
+          <p:nvPr/>
+        </p:nvSpPr>
+        <p:spPr>
+          <a:xfrm>
+            <a:off x="8732520" y="3630168"/>
+            <a:ext cx="2057400" cy="365760"/>
           </a:xfrm>
           <a:prstGeom prst="rect">
             <a:avLst/>
@@ -10154,7 +9948,7 @@
       </p:sp>
       <p:sp>
         <p:nvSpPr>
-          <p:cNvPr id="76" name="TextBox 76"/>
+          <p:cNvPr id="71" name="TextBox 71"/>
           <p:cNvSpPr txBox="1"/>
           <p:nvPr/>
         </p:nvSpPr>
@@ -10203,14 +9997,14 @@
       </p:sp>
       <p:sp>
         <p:nvSpPr>
-          <p:cNvPr id="77" name="TextBox 77"/>
+          <p:cNvPr id="72" name="TextBox 72"/>
           <p:cNvSpPr txBox="1"/>
           <p:nvPr/>
         </p:nvSpPr>
         <p:spPr>
           <a:xfrm>
             <a:off x="8001000" y="3995928"/>
-            <a:ext cx="685800" cy="365760"/>
+            <a:ext cx="731520" cy="365760"/>
           </a:xfrm>
           <a:prstGeom prst="rect">
             <a:avLst/>
@@ -10252,14 +10046,14 @@
       </p:sp>
       <p:sp>
         <p:nvSpPr>
-          <p:cNvPr id="78" name="TextBox 78"/>
-          <p:cNvSpPr txBox="1"/>
-          <p:nvPr/>
-        </p:nvSpPr>
-        <p:spPr>
-          <a:xfrm>
-            <a:off x="8686800" y="3995928"/>
-            <a:ext cx="2103120" cy="365760"/>
+          <p:cNvPr id="73" name="TextBox 73"/>
+          <p:cNvSpPr txBox="1"/>
+          <p:nvPr/>
+        </p:nvSpPr>
+        <p:spPr>
+          <a:xfrm>
+            <a:off x="8732520" y="3995928"/>
+            <a:ext cx="2057400" cy="365760"/>
           </a:xfrm>
           <a:prstGeom prst="rect">
             <a:avLst/>
@@ -10301,7 +10095,7 @@
       </p:sp>
       <p:sp>
         <p:nvSpPr>
-          <p:cNvPr id="79" name="TextBox 79"/>
+          <p:cNvPr id="74" name="TextBox 74"/>
           <p:cNvSpPr txBox="1"/>
           <p:nvPr/>
         </p:nvSpPr>
@@ -10350,14 +10144,14 @@
       </p:sp>
       <p:sp>
         <p:nvSpPr>
-          <p:cNvPr id="80" name="TextBox 80"/>
+          <p:cNvPr id="75" name="TextBox 75"/>
           <p:cNvSpPr txBox="1"/>
           <p:nvPr/>
         </p:nvSpPr>
         <p:spPr>
           <a:xfrm>
             <a:off x="8001000" y="4361688"/>
-            <a:ext cx="685800" cy="365760"/>
+            <a:ext cx="731520" cy="365760"/>
           </a:xfrm>
           <a:prstGeom prst="rect">
             <a:avLst/>
@@ -10399,14 +10193,14 @@
       </p:sp>
       <p:sp>
         <p:nvSpPr>
-          <p:cNvPr id="81" name="TextBox 81"/>
-          <p:cNvSpPr txBox="1"/>
-          <p:nvPr/>
-        </p:nvSpPr>
-        <p:spPr>
-          <a:xfrm>
-            <a:off x="8686800" y="4361688"/>
-            <a:ext cx="2103120" cy="365760"/>
+          <p:cNvPr id="76" name="TextBox 76"/>
+          <p:cNvSpPr txBox="1"/>
+          <p:nvPr/>
+        </p:nvSpPr>
+        <p:spPr>
+          <a:xfrm>
+            <a:off x="8732520" y="4361688"/>
+            <a:ext cx="2057400" cy="365760"/>
           </a:xfrm>
           <a:prstGeom prst="rect">
             <a:avLst/>
@@ -10448,7 +10242,7 @@
       </p:sp>
       <p:sp>
         <p:nvSpPr>
-          <p:cNvPr id="82" name="TextBox 82"/>
+          <p:cNvPr id="77" name="TextBox 77"/>
           <p:cNvSpPr txBox="1"/>
           <p:nvPr/>
         </p:nvSpPr>
@@ -10497,14 +10291,14 @@
       </p:sp>
       <p:sp>
         <p:nvSpPr>
-          <p:cNvPr id="83" name="TextBox 83"/>
+          <p:cNvPr id="78" name="TextBox 78"/>
           <p:cNvSpPr txBox="1"/>
           <p:nvPr/>
         </p:nvSpPr>
         <p:spPr>
           <a:xfrm>
             <a:off x="8001000" y="4800600"/>
-            <a:ext cx="3977640" cy="1097280"/>
+            <a:ext cx="3977640" cy="1005840"/>
           </a:xfrm>
           <a:prstGeom prst="rect">
             <a:avLst/>
@@ -10537,7 +10331,7 @@
                 <a:latin typeface="Arial"/>
                 <a:cs typeface="Arial"/>
               </a:rPr>
-              <a:t>Count of IHCAFE releases</a:t>
+              <a:t>Count of releases</a:t>
             </a:r>
           </a:p>
           <a:p>
@@ -10558,7 +10352,7 @@
                 <a:latin typeface="Arial"/>
                 <a:cs typeface="Arial"/>
               </a:rPr>
-              <a:t>1990–2004: 3 bred by IHCAFE (IHCAFE 90, Lempira, Parainema)</a:t>
+              <a:t>Bred by IHCAFE: 1990, 1998, 2004 · none 2005–2023</a:t>
             </a:r>
           </a:p>
           <a:p>
@@ -10579,7 +10373,7 @@
                 <a:latin typeface="Arial"/>
                 <a:cs typeface="Arial"/>
               </a:rPr>
-              <a:t>2005–2023: none found</a:t>
+              <a:t>Sep 2023: "at least 4" announced → Feb 2024: 3 presented (bred abroad)</a:t>
             </a:r>
           </a:p>
           <a:p>
@@ -10593,42 +10387,21 @@
               <a:buNone/>
             </a:pPr>
             <a:r>
-              <a:rPr lang="en-GB" sz="800" dirty="0">
-                <a:solidFill>
-                  <a:srgbClr val="262626"/>
-                </a:solidFill>
-                <a:latin typeface="Arial"/>
-                <a:cs typeface="Arial"/>
-              </a:rPr>
-              <a:t>2024: 3 bred abroad ⚠ · 2026: 2 in release process ⚠</a:t>
-            </a:r>
-          </a:p>
-          <a:p>
-            <a:pPr algn="l" marL="0" indent="0">
-              <a:spcBef>
-                <a:spcPts val="0"/>
-              </a:spcBef>
-              <a:spcAft>
-                <a:spcPts val="0"/>
-              </a:spcAft>
-              <a:buNone/>
-            </a:pPr>
-            <a:r>
-              <a:rPr lang="en-GB" sz="800" b="1" dirty="0">
-                <a:solidFill>
-                  <a:srgbClr val="262626"/>
-                </a:solidFill>
-                <a:latin typeface="Arial"/>
-                <a:cs typeface="Arial"/>
-              </a:rPr>
-              <a:t>USDA 2020–21 names only Parainema as still resistant</a:t>
-            </a:r>
-          </a:p>
-        </p:txBody>
-      </p:sp>
-      <p:sp>
-        <p:nvSpPr>
-          <p:cNvPr id="84" name="TextBox 84"/>
+              <a:rPr lang="en-GB" sz="700" dirty="0">
+                <a:solidFill>
+                  <a:srgbClr val="7F7F7F"/>
+                </a:solidFill>
+                <a:latin typeface="Arial"/>
+                <a:cs typeface="Arial"/>
+              </a:rPr>
+              <a:t>⚠ = pages not downloadable (IHCAFE bulletin, 2017 and 2020 articles)</a:t>
+            </a:r>
+          </a:p>
+        </p:txBody>
+      </p:sp>
+      <p:sp>
+        <p:nvSpPr>
+          <p:cNvPr id="79" name="TextBox 79"/>
           <p:cNvSpPr txBox="1"/>
           <p:nvPr/>
         </p:nvSpPr>
@@ -10668,7 +10441,7 @@
                 <a:latin typeface="Arial"/>
                 <a:cs typeface="Arial"/>
               </a:rPr>
-              <a:t>✔ USDA FAS Coffee Annual Honduras 2013–2025. ⚠ web extracts (pages blocked here): release years; Lempira weakening from 2015 (PROMECAFE 2019); IHCAFE 90 at 80 % (La Prensa 2017); IHCAFE SAT bulletin No 8, Oct 2017: Lempira = 56,08 % of monitored farms and 67,74 % of susceptible ones → susceptible 82,8 %, resistant 17,2 %; 2024 and 2026 releases.</a:t>
+              <a:t>✔ Morales &amp; Grajeda (IHCAFE), "Durabilidad de la resistencia genética a la roya … al 2019", PROMECAFE symposium 2019; World Coffee Research variety pages; El Heraldo 29 Feb 2024; La Prensa 29 Sep 2023; USDA Coffee Annual 2013–2021. The IHCAFE study also lists the Icatu 75 line as susceptible since 2016 and Obatá as 20 % susceptible.</a:t>
             </a:r>
           </a:p>
         </p:txBody>
@@ -12330,7 +12103,7 @@
                 <a:latin typeface="Arial"/>
                 <a:cs typeface="Arial"/>
               </a:rPr>
-              <a:t>2012–13 rust loans were due by 2019 (USDA), when prices were 2,9 $/kg. 2018 loan: L200/qq ≈ 8,4 $ (8 % of the 107 $ export price), repaid at 1,50 $/qq</a:t>
+              <a:t>2012–13 rust loans (10 %, 7 years) were due by 2019, when prices were 2,9 $/kg. 2018 loan: L200/qq ≈ 8,4 $ (8 % of the 107 $ export price), repaid at 1,50 $/qq</a:t>
             </a:r>
           </a:p>
           <a:p>
@@ -12572,7 +12345,7 @@
         </p:nvSpPr>
         <p:spPr>
           <a:xfrm>
-            <a:off x="3376422" y="4628239"/>
+            <a:off x="3376422" y="4616652"/>
             <a:ext cx="731520" cy="201168"/>
           </a:xfrm>
           <a:prstGeom prst="rect">
@@ -12606,7 +12379,7 @@
                 <a:latin typeface="Arial"/>
                 <a:cs typeface="Arial"/>
               </a:rPr>
-              <a:t>12,2</a:t>
+              <a:t>12,6</a:t>
             </a:r>
           </a:p>
         </p:txBody>
@@ -12930,7 +12703,7 @@
                 <a:latin typeface="Arial"/>
                 <a:cs typeface="Arial"/>
               </a:rPr>
-              <a:t>rust credit ⚠</a:t>
+              <a:t>rust credit*</a:t>
             </a:r>
           </a:p>
         </p:txBody>
@@ -13113,7 +12886,7 @@
                 <a:latin typeface="Arial"/>
                 <a:cs typeface="Arial"/>
               </a:rPr>
-              <a:t>2019</a:t>
+              <a:t>2018</a:t>
             </a:r>
           </a:p>
           <a:p>
@@ -13134,7 +12907,7 @@
                 <a:latin typeface="Arial"/>
                 <a:cs typeface="Arial"/>
               </a:rPr>
-              <a:t>debt fund ⚠</a:t>
+              <a:t>BANHPROVI fund</a:t>
             </a:r>
           </a:p>
         </p:txBody>
@@ -13407,7 +13180,7 @@
                 <a:latin typeface="Arial"/>
                 <a:cs typeface="Arial"/>
               </a:rPr>
-              <a:t>amount in a USDA report (read)</a:t>
+              <a:t>amount read (USDA report or article)</a:t>
             </a:r>
           </a:p>
         </p:txBody>
@@ -13420,7 +13193,7 @@
         </p:nvSpPr>
         <p:spPr>
           <a:xfrm>
-            <a:off x="2726741" y="6172200"/>
+            <a:off x="3025201" y="6172200"/>
             <a:ext cx="164592" cy="128016"/>
           </a:xfrm>
           <a:prstGeom prst="rect">
@@ -13442,7 +13215,7 @@
         </p:nvSpPr>
         <p:spPr>
           <a:xfrm>
-            <a:off x="3010205" y="6135624"/>
+            <a:off x="3308665" y="6135624"/>
             <a:ext cx="2926080" cy="201168"/>
           </a:xfrm>
           <a:prstGeom prst="rect">
@@ -14015,7 +13788,7 @@
                 <a:latin typeface="Arial"/>
                 <a:cs typeface="Arial"/>
               </a:rPr>
-              <a:t>⚠ Rust emergency credit (banks, BANHPROVI, BANADESA)</a:t>
+              <a:t>Rust credit made available (banks, BCH, BANHPROVI, BANADESA, IHCAFE)</a:t>
             </a:r>
           </a:p>
         </p:txBody>
@@ -14064,7 +13837,7 @@
                 <a:latin typeface="Arial"/>
                 <a:cs typeface="Arial"/>
               </a:rPr>
-              <a:t>growers hit by rust; BANADESA loans up to L25,000; to be repaid by 2019 (USDA)</a:t>
+              <a:t>L335 M actually used by April 2014; BANADESA loans up to L25,000, banks up to L150,000; 10 % interest, 7 years; to be repaid by 2019 (USDA)</a:t>
             </a:r>
           </a:p>
         </p:txBody>
@@ -14505,7 +14278,7 @@
                 <a:latin typeface="Arial"/>
                 <a:cs typeface="Arial"/>
               </a:rPr>
-              <a:t>all registered growers who ask</a:t>
+              <a:t>all growers who ask</a:t>
             </a:r>
           </a:p>
         </p:txBody>
@@ -14554,7 +14327,7 @@
                 <a:latin typeface="Arial"/>
                 <a:cs typeface="Arial"/>
               </a:rPr>
-              <a:t>2019</a:t>
+              <a:t>2018</a:t>
             </a:r>
           </a:p>
         </p:txBody>
@@ -14603,7 +14376,7 @@
                 <a:latin typeface="Arial"/>
                 <a:cs typeface="Arial"/>
               </a:rPr>
-              <a:t>⚠ Decreto 47-2018 debt readjustment + BANHPROVI coffee fund</a:t>
+              <a:t>Fondo para el Sector Cafetero (BANHPROVI)</a:t>
             </a:r>
           </a:p>
         </p:txBody>
@@ -14652,7 +14425,7 @@
                 <a:latin typeface="Arial"/>
                 <a:cs typeface="Arial"/>
               </a:rPr>
-              <a:t>&gt; 55,000 growers; up to 20 years at 2 %</a:t>
+              <a:t>backs refinancing and debt readjustment of growers; L300 M in three instalments</a:t>
             </a:r>
           </a:p>
         </p:txBody>
@@ -15287,7 +15060,7 @@
                 <a:latin typeface="Arial"/>
                 <a:cs typeface="Arial"/>
               </a:rPr>
-              <a:t>Sources: USDA FAS Coffee Annual Honduras 2011, 2015–2017, 2020, 2021, 2024 (amounts, terms, deductions); FAOSTAT exchange rates (L per US$: 2013 20,35, 2019 24,51, 2025 25,95). ⚠ = web-search extracts (El Heraldo, La Prensa, TNH, La Tribuna); the pages could not be opened. The 2018 decree text (L1 900 M, L200/qq) is also an extract; USDA wrote "about $25 per 100 pounds".</a:t>
+              <a:t>*2013: L1 715 M made available at 10 %, 7 years, but only L335 M (≈ 16 M$) used by April 2014 (El Heraldo, 7 Apr 2014, read). Sources: USDA FAS Coffee Annual Honduras 2011, 2015–2017, 2020, 2021, 2024 (amounts, terms, deductions); FAOSTAT exchange rates (L per US$: 2013 20,35, 2019 24,51, 2025 25,95). ⚠ = web-search extract, page not opened (2025 bono, 2021 debt). Decree 93-2018 terms read in El Heraldo, 29 Aug 2018: L200 per quintal oro (USDA wrote "about $25 per 100 pounds", which is wrong).</a:t>
             </a:r>
           </a:p>
         </p:txBody>

</xml_diff>

<commit_message>
Verify the August 2017 resistant-share figure and drop the unsourced seed-demand split
La Prensa of 24 Aug 2017 (downloaded) confirms 60 % of the national coffee
park in improved rust-resistant plants and IHCAFE 90 at 80 % / Parainema at
100 % resistance to the new strain. The 65 % Lempira seed-demand figure is not
in that article; its source could not be found, so it is removed.

Co-Authored-By: Claude Opus 5.5 <noreply@anthropic.com>
Claude-Session: https://claude.ai/code/session_01GCSUFXh2mYdWNgg7VCeE1G
</commit_message>
<xml_diff>
--- a/research/honduras/slides/Honduras_price_finance_varieties.pptx
+++ b/research/honduras/slides/Honduras_price_finance_varieties.pptx
@@ -9892,7 +9892,7 @@
                 <a:latin typeface="Arial"/>
                 <a:cs typeface="Arial"/>
               </a:rPr>
-              <a:t>Aug 2017</a:t>
+              <a:t>24 Aug 2017</a:t>
             </a:r>
           </a:p>
         </p:txBody>
@@ -9941,7 +9941,7 @@
                 <a:latin typeface="Arial"/>
                 <a:cs typeface="Arial"/>
               </a:rPr>
-              <a:t>60 % of the park; seed: 65 % Lempira</a:t>
+              <a:t>60 % of the park (IHCAFE adviser)</a:t>
             </a:r>
           </a:p>
         </p:txBody>
@@ -9990,7 +9990,7 @@
                 <a:latin typeface="Arial"/>
                 <a:cs typeface="Arial"/>
               </a:rPr>
-              <a:t>⚠ La Prensa, 25 Aug 2017</a:t>
+              <a:t>✔ La Prensa, 24 Aug 2017</a:t>
             </a:r>
           </a:p>
         </p:txBody>
@@ -10394,7 +10394,7 @@
                 <a:latin typeface="Arial"/>
                 <a:cs typeface="Arial"/>
               </a:rPr>
-              <a:t>⚠ = pages not downloadable (IHCAFE bulletin, 2017 and 2020 articles)</a:t>
+              <a:t>⚠ = page not downloadable (IHCAFE bulletin Oct 2017, 2020 article)</a:t>
             </a:r>
           </a:p>
         </p:txBody>
@@ -10441,7 +10441,7 @@
                 <a:latin typeface="Arial"/>
                 <a:cs typeface="Arial"/>
               </a:rPr>
-              <a:t>✔ Morales &amp; Grajeda (IHCAFE), "Durabilidad de la resistencia genética a la roya … al 2019", PROMECAFE symposium 2019; World Coffee Research variety pages; El Heraldo 29 Feb 2024; La Prensa 29 Sep 2023; USDA Coffee Annual 2013–2021. The IHCAFE study also lists the Icatu 75 line as susceptible since 2016 and Obatá as 20 % susceptible.</a:t>
+              <a:t>✔ Morales &amp; Grajeda (IHCAFE), "Durabilidad de la resistencia genética a la roya … al 2019", PROMECAFE symposium 2019; World Coffee Research variety pages; El Heraldo 29 Feb 2024; La Prensa 24 Aug 2017 and 29 Sep 2023; USDA Coffee Annual 2013–2021. The IHCAFE study also lists the Icatu 75 line as susceptible since 2016 and Obatá as 20 % susceptible.</a:t>
             </a:r>
           </a:p>
         </p:txBody>

</xml_diff>